<commit_message>
feat: enforce strict verified badge requirements for prerequisite and phase unlocking
</commit_message>
<xml_diff>
--- a/CareerGraph_Project_Presentation.pptx
+++ b/CareerGraph_Project_Presentation.pptx
@@ -5,21 +5,21 @@
     <p:sldMasterId id="2147483648" r:id="rId1"/>
   </p:sldMasterIdLst>
   <p:sldIdLst>
-    <p:sldId id="256" r:id="rId7"/>
-    <p:sldId id="257" r:id="rId8"/>
-    <p:sldId id="258" r:id="rId9"/>
-    <p:sldId id="259" r:id="rId10"/>
-    <p:sldId id="260" r:id="rId11"/>
-    <p:sldId id="261" r:id="rId12"/>
-    <p:sldId id="262" r:id="rId13"/>
-    <p:sldId id="263" r:id="rId14"/>
-    <p:sldId id="264" r:id="rId15"/>
-    <p:sldId id="265" r:id="rId16"/>
-    <p:sldId id="266" r:id="rId17"/>
-    <p:sldId id="267" r:id="rId18"/>
-    <p:sldId id="268" r:id="rId19"/>
+    <p:sldId id="256" r:id="rId2"/>
+    <p:sldId id="257" r:id="rId3"/>
+    <p:sldId id="258" r:id="rId4"/>
+    <p:sldId id="259" r:id="rId5"/>
+    <p:sldId id="260" r:id="rId6"/>
+    <p:sldId id="261" r:id="rId7"/>
+    <p:sldId id="262" r:id="rId8"/>
+    <p:sldId id="263" r:id="rId9"/>
+    <p:sldId id="264" r:id="rId10"/>
+    <p:sldId id="265" r:id="rId11"/>
+    <p:sldId id="266" r:id="rId12"/>
+    <p:sldId id="267" r:id="rId13"/>
+    <p:sldId id="268" r:id="rId14"/>
   </p:sldIdLst>
-  <p:sldSz cx="12191695" cy="6858000" type="screen4x3"/>
+  <p:sldSz cx="12192000" cy="6858000"/>
   <p:notesSz cx="6858000" cy="9144000"/>
   <p:defaultTextStyle>
     <a:defPPr>
@@ -116,6 +116,22 @@
       </a:defRPr>
     </a:lvl9pPr>
   </p:defaultTextStyle>
+  <p:extLst>
+    <p:ext uri="{EFAFB233-063F-42B5-8137-9DF3F51BA10A}">
+      <p15:sldGuideLst xmlns:p15="http://schemas.microsoft.com/office/powerpoint/2012/main">
+        <p15:guide id="1" orient="horz" pos="2160">
+          <p15:clr>
+            <a:srgbClr val="A4A3A4"/>
+          </p15:clr>
+        </p15:guide>
+        <p15:guide id="2" pos="2880">
+          <p15:clr>
+            <a:srgbClr val="A4A3A4"/>
+          </p15:clr>
+        </p15:guide>
+      </p15:sldGuideLst>
+    </p:ext>
+  </p:extLst>
 </p:presentation>
 </file>
 
@@ -157,10 +173,9 @@
           <a:lstStyle/>
           <a:p>
             <a:r>
-              <a:rPr lang="en-US" smtClean="0"/>
+              <a:rPr lang="en-US"/>
               <a:t>Click to edit Master title style</a:t>
             </a:r>
-            <a:endParaRPr lang="en-US"/>
           </a:p>
         </p:txBody>
       </p:sp>
@@ -276,10 +291,9 @@
           </a:lstStyle>
           <a:p>
             <a:r>
-              <a:rPr lang="en-US" smtClean="0"/>
+              <a:rPr lang="en-US"/>
               <a:t>Click to edit Master subtitle style</a:t>
             </a:r>
-            <a:endParaRPr lang="en-US"/>
           </a:p>
         </p:txBody>
       </p:sp>
@@ -300,7 +314,7 @@
           <a:p>
             <a:fld id="{5BCAD085-E8A6-8845-BD4E-CB4CCA059FC4}" type="datetimeFigureOut">
               <a:rPr lang="en-US" smtClean="0"/>
-              <a:t>1/27/13</a:t>
+              <a:t>9/29/26</a:t>
             </a:fld>
             <a:endParaRPr lang="en-US"/>
           </a:p>
@@ -394,10 +408,9 @@
           <a:lstStyle/>
           <a:p>
             <a:r>
-              <a:rPr lang="en-US" smtClean="0"/>
+              <a:rPr lang="en-US"/>
               <a:t>Click to edit Master title style</a:t>
             </a:r>
-            <a:endParaRPr lang="en-US"/>
           </a:p>
         </p:txBody>
       </p:sp>
@@ -418,38 +431,37 @@
           <a:p>
             <a:pPr lvl="0"/>
             <a:r>
-              <a:rPr lang="en-US" smtClean="0"/>
+              <a:rPr lang="en-US"/>
               <a:t>Click to edit Master text styles</a:t>
             </a:r>
           </a:p>
           <a:p>
             <a:pPr lvl="1"/>
             <a:r>
-              <a:rPr lang="en-US" smtClean="0"/>
+              <a:rPr lang="en-US"/>
               <a:t>Second level</a:t>
             </a:r>
           </a:p>
           <a:p>
             <a:pPr lvl="2"/>
             <a:r>
-              <a:rPr lang="en-US" smtClean="0"/>
+              <a:rPr lang="en-US"/>
               <a:t>Third level</a:t>
             </a:r>
           </a:p>
           <a:p>
             <a:pPr lvl="3"/>
             <a:r>
-              <a:rPr lang="en-US" smtClean="0"/>
+              <a:rPr lang="en-US"/>
               <a:t>Fourth level</a:t>
             </a:r>
           </a:p>
           <a:p>
             <a:pPr lvl="4"/>
             <a:r>
-              <a:rPr lang="en-US" smtClean="0"/>
+              <a:rPr lang="en-US"/>
               <a:t>Fifth level</a:t>
             </a:r>
-            <a:endParaRPr lang="en-US"/>
           </a:p>
         </p:txBody>
       </p:sp>
@@ -470,7 +482,7 @@
           <a:p>
             <a:fld id="{5BCAD085-E8A6-8845-BD4E-CB4CCA059FC4}" type="datetimeFigureOut">
               <a:rPr lang="en-US" smtClean="0"/>
-              <a:t>1/27/13</a:t>
+              <a:t>9/29/26</a:t>
             </a:fld>
             <a:endParaRPr lang="en-US"/>
           </a:p>
@@ -569,10 +581,9 @@
           <a:lstStyle/>
           <a:p>
             <a:r>
-              <a:rPr lang="en-US" smtClean="0"/>
+              <a:rPr lang="en-US"/>
               <a:t>Click to edit Master title style</a:t>
             </a:r>
-            <a:endParaRPr lang="en-US"/>
           </a:p>
         </p:txBody>
       </p:sp>
@@ -598,38 +609,37 @@
           <a:p>
             <a:pPr lvl="0"/>
             <a:r>
-              <a:rPr lang="en-US" smtClean="0"/>
+              <a:rPr lang="en-US"/>
               <a:t>Click to edit Master text styles</a:t>
             </a:r>
           </a:p>
           <a:p>
             <a:pPr lvl="1"/>
             <a:r>
-              <a:rPr lang="en-US" smtClean="0"/>
+              <a:rPr lang="en-US"/>
               <a:t>Second level</a:t>
             </a:r>
           </a:p>
           <a:p>
             <a:pPr lvl="2"/>
             <a:r>
-              <a:rPr lang="en-US" smtClean="0"/>
+              <a:rPr lang="en-US"/>
               <a:t>Third level</a:t>
             </a:r>
           </a:p>
           <a:p>
             <a:pPr lvl="3"/>
             <a:r>
-              <a:rPr lang="en-US" smtClean="0"/>
+              <a:rPr lang="en-US"/>
               <a:t>Fourth level</a:t>
             </a:r>
           </a:p>
           <a:p>
             <a:pPr lvl="4"/>
             <a:r>
-              <a:rPr lang="en-US" smtClean="0"/>
+              <a:rPr lang="en-US"/>
               <a:t>Fifth level</a:t>
             </a:r>
-            <a:endParaRPr lang="en-US"/>
           </a:p>
         </p:txBody>
       </p:sp>
@@ -650,7 +660,7 @@
           <a:p>
             <a:fld id="{5BCAD085-E8A6-8845-BD4E-CB4CCA059FC4}" type="datetimeFigureOut">
               <a:rPr lang="en-US" smtClean="0"/>
-              <a:t>1/27/13</a:t>
+              <a:t>9/29/26</a:t>
             </a:fld>
             <a:endParaRPr lang="en-US"/>
           </a:p>
@@ -744,10 +754,9 @@
           <a:lstStyle/>
           <a:p>
             <a:r>
-              <a:rPr lang="en-US" smtClean="0"/>
+              <a:rPr lang="en-US"/>
               <a:t>Click to edit Master title style</a:t>
             </a:r>
-            <a:endParaRPr lang="en-US"/>
           </a:p>
         </p:txBody>
       </p:sp>
@@ -768,38 +777,37 @@
           <a:p>
             <a:pPr lvl="0"/>
             <a:r>
-              <a:rPr lang="en-US" smtClean="0"/>
+              <a:rPr lang="en-US"/>
               <a:t>Click to edit Master text styles</a:t>
             </a:r>
           </a:p>
           <a:p>
             <a:pPr lvl="1"/>
             <a:r>
-              <a:rPr lang="en-US" smtClean="0"/>
+              <a:rPr lang="en-US"/>
               <a:t>Second level</a:t>
             </a:r>
           </a:p>
           <a:p>
             <a:pPr lvl="2"/>
             <a:r>
-              <a:rPr lang="en-US" smtClean="0"/>
+              <a:rPr lang="en-US"/>
               <a:t>Third level</a:t>
             </a:r>
           </a:p>
           <a:p>
             <a:pPr lvl="3"/>
             <a:r>
-              <a:rPr lang="en-US" smtClean="0"/>
+              <a:rPr lang="en-US"/>
               <a:t>Fourth level</a:t>
             </a:r>
           </a:p>
           <a:p>
             <a:pPr lvl="4"/>
             <a:r>
-              <a:rPr lang="en-US" smtClean="0"/>
+              <a:rPr lang="en-US"/>
               <a:t>Fifth level</a:t>
             </a:r>
-            <a:endParaRPr lang="en-US"/>
           </a:p>
         </p:txBody>
       </p:sp>
@@ -820,7 +828,7 @@
           <a:p>
             <a:fld id="{5BCAD085-E8A6-8845-BD4E-CB4CCA059FC4}" type="datetimeFigureOut">
               <a:rPr lang="en-US" smtClean="0"/>
-              <a:t>1/27/13</a:t>
+              <a:t>9/29/26</a:t>
             </a:fld>
             <a:endParaRPr lang="en-US"/>
           </a:p>
@@ -923,10 +931,9 @@
           </a:lstStyle>
           <a:p>
             <a:r>
-              <a:rPr lang="en-US" smtClean="0"/>
+              <a:rPr lang="en-US"/>
               <a:t>Click to edit Master title style</a:t>
             </a:r>
-            <a:endParaRPr lang="en-US"/>
           </a:p>
         </p:txBody>
       </p:sp>
@@ -1043,7 +1050,7 @@
           <a:p>
             <a:pPr lvl="0"/>
             <a:r>
-              <a:rPr lang="en-US" smtClean="0"/>
+              <a:rPr lang="en-US"/>
               <a:t>Click to edit Master text styles</a:t>
             </a:r>
           </a:p>
@@ -1066,7 +1073,7 @@
           <a:p>
             <a:fld id="{5BCAD085-E8A6-8845-BD4E-CB4CCA059FC4}" type="datetimeFigureOut">
               <a:rPr lang="en-US" smtClean="0"/>
-              <a:t>1/27/13</a:t>
+              <a:t>9/29/26</a:t>
             </a:fld>
             <a:endParaRPr lang="en-US"/>
           </a:p>
@@ -1160,10 +1167,9 @@
           <a:lstStyle/>
           <a:p>
             <a:r>
-              <a:rPr lang="en-US" smtClean="0"/>
+              <a:rPr lang="en-US"/>
               <a:t>Click to edit Master title style</a:t>
             </a:r>
-            <a:endParaRPr lang="en-US"/>
           </a:p>
         </p:txBody>
       </p:sp>
@@ -1217,38 +1223,37 @@
           <a:p>
             <a:pPr lvl="0"/>
             <a:r>
-              <a:rPr lang="en-US" smtClean="0"/>
+              <a:rPr lang="en-US"/>
               <a:t>Click to edit Master text styles</a:t>
             </a:r>
           </a:p>
           <a:p>
             <a:pPr lvl="1"/>
             <a:r>
-              <a:rPr lang="en-US" smtClean="0"/>
+              <a:rPr lang="en-US"/>
               <a:t>Second level</a:t>
             </a:r>
           </a:p>
           <a:p>
             <a:pPr lvl="2"/>
             <a:r>
-              <a:rPr lang="en-US" smtClean="0"/>
+              <a:rPr lang="en-US"/>
               <a:t>Third level</a:t>
             </a:r>
           </a:p>
           <a:p>
             <a:pPr lvl="3"/>
             <a:r>
-              <a:rPr lang="en-US" smtClean="0"/>
+              <a:rPr lang="en-US"/>
               <a:t>Fourth level</a:t>
             </a:r>
           </a:p>
           <a:p>
             <a:pPr lvl="4"/>
             <a:r>
-              <a:rPr lang="en-US" smtClean="0"/>
+              <a:rPr lang="en-US"/>
               <a:t>Fifth level</a:t>
             </a:r>
-            <a:endParaRPr lang="en-US"/>
           </a:p>
         </p:txBody>
       </p:sp>
@@ -1302,38 +1307,37 @@
           <a:p>
             <a:pPr lvl="0"/>
             <a:r>
-              <a:rPr lang="en-US" smtClean="0"/>
+              <a:rPr lang="en-US"/>
               <a:t>Click to edit Master text styles</a:t>
             </a:r>
           </a:p>
           <a:p>
             <a:pPr lvl="1"/>
             <a:r>
-              <a:rPr lang="en-US" smtClean="0"/>
+              <a:rPr lang="en-US"/>
               <a:t>Second level</a:t>
             </a:r>
           </a:p>
           <a:p>
             <a:pPr lvl="2"/>
             <a:r>
-              <a:rPr lang="en-US" smtClean="0"/>
+              <a:rPr lang="en-US"/>
               <a:t>Third level</a:t>
             </a:r>
           </a:p>
           <a:p>
             <a:pPr lvl="3"/>
             <a:r>
-              <a:rPr lang="en-US" smtClean="0"/>
+              <a:rPr lang="en-US"/>
               <a:t>Fourth level</a:t>
             </a:r>
           </a:p>
           <a:p>
             <a:pPr lvl="4"/>
             <a:r>
-              <a:rPr lang="en-US" smtClean="0"/>
+              <a:rPr lang="en-US"/>
               <a:t>Fifth level</a:t>
             </a:r>
-            <a:endParaRPr lang="en-US"/>
           </a:p>
         </p:txBody>
       </p:sp>
@@ -1354,7 +1358,7 @@
           <a:p>
             <a:fld id="{5BCAD085-E8A6-8845-BD4E-CB4CCA059FC4}" type="datetimeFigureOut">
               <a:rPr lang="en-US" smtClean="0"/>
-              <a:t>1/27/13</a:t>
+              <a:t>9/29/26</a:t>
             </a:fld>
             <a:endParaRPr lang="en-US"/>
           </a:p>
@@ -1452,10 +1456,9 @@
           </a:lstStyle>
           <a:p>
             <a:r>
-              <a:rPr lang="en-US" smtClean="0"/>
+              <a:rPr lang="en-US"/>
               <a:t>Click to edit Master title style</a:t>
             </a:r>
-            <a:endParaRPr lang="en-US"/>
           </a:p>
         </p:txBody>
       </p:sp>
@@ -1518,7 +1521,7 @@
           <a:p>
             <a:pPr lvl="0"/>
             <a:r>
-              <a:rPr lang="en-US" smtClean="0"/>
+              <a:rPr lang="en-US"/>
               <a:t>Click to edit Master text styles</a:t>
             </a:r>
           </a:p>
@@ -1574,38 +1577,37 @@
           <a:p>
             <a:pPr lvl="0"/>
             <a:r>
-              <a:rPr lang="en-US" smtClean="0"/>
+              <a:rPr lang="en-US"/>
               <a:t>Click to edit Master text styles</a:t>
             </a:r>
           </a:p>
           <a:p>
             <a:pPr lvl="1"/>
             <a:r>
-              <a:rPr lang="en-US" smtClean="0"/>
+              <a:rPr lang="en-US"/>
               <a:t>Second level</a:t>
             </a:r>
           </a:p>
           <a:p>
             <a:pPr lvl="2"/>
             <a:r>
-              <a:rPr lang="en-US" smtClean="0"/>
+              <a:rPr lang="en-US"/>
               <a:t>Third level</a:t>
             </a:r>
           </a:p>
           <a:p>
             <a:pPr lvl="3"/>
             <a:r>
-              <a:rPr lang="en-US" smtClean="0"/>
+              <a:rPr lang="en-US"/>
               <a:t>Fourth level</a:t>
             </a:r>
           </a:p>
           <a:p>
             <a:pPr lvl="4"/>
             <a:r>
-              <a:rPr lang="en-US" smtClean="0"/>
+              <a:rPr lang="en-US"/>
               <a:t>Fifth level</a:t>
             </a:r>
-            <a:endParaRPr lang="en-US"/>
           </a:p>
         </p:txBody>
       </p:sp>
@@ -1668,7 +1670,7 @@
           <a:p>
             <a:pPr lvl="0"/>
             <a:r>
-              <a:rPr lang="en-US" smtClean="0"/>
+              <a:rPr lang="en-US"/>
               <a:t>Click to edit Master text styles</a:t>
             </a:r>
           </a:p>
@@ -1724,38 +1726,37 @@
           <a:p>
             <a:pPr lvl="0"/>
             <a:r>
-              <a:rPr lang="en-US" smtClean="0"/>
+              <a:rPr lang="en-US"/>
               <a:t>Click to edit Master text styles</a:t>
             </a:r>
           </a:p>
           <a:p>
             <a:pPr lvl="1"/>
             <a:r>
-              <a:rPr lang="en-US" smtClean="0"/>
+              <a:rPr lang="en-US"/>
               <a:t>Second level</a:t>
             </a:r>
           </a:p>
           <a:p>
             <a:pPr lvl="2"/>
             <a:r>
-              <a:rPr lang="en-US" smtClean="0"/>
+              <a:rPr lang="en-US"/>
               <a:t>Third level</a:t>
             </a:r>
           </a:p>
           <a:p>
             <a:pPr lvl="3"/>
             <a:r>
-              <a:rPr lang="en-US" smtClean="0"/>
+              <a:rPr lang="en-US"/>
               <a:t>Fourth level</a:t>
             </a:r>
           </a:p>
           <a:p>
             <a:pPr lvl="4"/>
             <a:r>
-              <a:rPr lang="en-US" smtClean="0"/>
+              <a:rPr lang="en-US"/>
               <a:t>Fifth level</a:t>
             </a:r>
-            <a:endParaRPr lang="en-US"/>
           </a:p>
         </p:txBody>
       </p:sp>
@@ -1776,7 +1777,7 @@
           <a:p>
             <a:fld id="{5BCAD085-E8A6-8845-BD4E-CB4CCA059FC4}" type="datetimeFigureOut">
               <a:rPr lang="en-US" smtClean="0"/>
-              <a:t>1/27/13</a:t>
+              <a:t>9/29/26</a:t>
             </a:fld>
             <a:endParaRPr lang="en-US"/>
           </a:p>
@@ -1870,10 +1871,9 @@
           <a:lstStyle/>
           <a:p>
             <a:r>
-              <a:rPr lang="en-US" smtClean="0"/>
+              <a:rPr lang="en-US"/>
               <a:t>Click to edit Master title style</a:t>
             </a:r>
-            <a:endParaRPr lang="en-US"/>
           </a:p>
         </p:txBody>
       </p:sp>
@@ -1894,7 +1894,7 @@
           <a:p>
             <a:fld id="{5BCAD085-E8A6-8845-BD4E-CB4CCA059FC4}" type="datetimeFigureOut">
               <a:rPr lang="en-US" smtClean="0"/>
-              <a:t>1/27/13</a:t>
+              <a:t>9/29/26</a:t>
             </a:fld>
             <a:endParaRPr lang="en-US"/>
           </a:p>
@@ -1989,7 +1989,7 @@
           <a:p>
             <a:fld id="{5BCAD085-E8A6-8845-BD4E-CB4CCA059FC4}" type="datetimeFigureOut">
               <a:rPr lang="en-US" smtClean="0"/>
-              <a:t>1/27/13</a:t>
+              <a:t>9/29/26</a:t>
             </a:fld>
             <a:endParaRPr lang="en-US"/>
           </a:p>
@@ -2092,10 +2092,9 @@
           </a:lstStyle>
           <a:p>
             <a:r>
-              <a:rPr lang="en-US" smtClean="0"/>
+              <a:rPr lang="en-US"/>
               <a:t>Click to edit Master title style</a:t>
             </a:r>
-            <a:endParaRPr lang="en-US"/>
           </a:p>
         </p:txBody>
       </p:sp>
@@ -2149,38 +2148,37 @@
           <a:p>
             <a:pPr lvl="0"/>
             <a:r>
-              <a:rPr lang="en-US" smtClean="0"/>
+              <a:rPr lang="en-US"/>
               <a:t>Click to edit Master text styles</a:t>
             </a:r>
           </a:p>
           <a:p>
             <a:pPr lvl="1"/>
             <a:r>
-              <a:rPr lang="en-US" smtClean="0"/>
+              <a:rPr lang="en-US"/>
               <a:t>Second level</a:t>
             </a:r>
           </a:p>
           <a:p>
             <a:pPr lvl="2"/>
             <a:r>
-              <a:rPr lang="en-US" smtClean="0"/>
+              <a:rPr lang="en-US"/>
               <a:t>Third level</a:t>
             </a:r>
           </a:p>
           <a:p>
             <a:pPr lvl="3"/>
             <a:r>
-              <a:rPr lang="en-US" smtClean="0"/>
+              <a:rPr lang="en-US"/>
               <a:t>Fourth level</a:t>
             </a:r>
           </a:p>
           <a:p>
             <a:pPr lvl="4"/>
             <a:r>
-              <a:rPr lang="en-US" smtClean="0"/>
+              <a:rPr lang="en-US"/>
               <a:t>Fifth level</a:t>
             </a:r>
-            <a:endParaRPr lang="en-US"/>
           </a:p>
         </p:txBody>
       </p:sp>
@@ -2243,7 +2241,7 @@
           <a:p>
             <a:pPr lvl="0"/>
             <a:r>
-              <a:rPr lang="en-US" smtClean="0"/>
+              <a:rPr lang="en-US"/>
               <a:t>Click to edit Master text styles</a:t>
             </a:r>
           </a:p>
@@ -2266,7 +2264,7 @@
           <a:p>
             <a:fld id="{5BCAD085-E8A6-8845-BD4E-CB4CCA059FC4}" type="datetimeFigureOut">
               <a:rPr lang="en-US" smtClean="0"/>
-              <a:t>1/27/13</a:t>
+              <a:t>9/29/26</a:t>
             </a:fld>
             <a:endParaRPr lang="en-US"/>
           </a:p>
@@ -2369,10 +2367,9 @@
           </a:lstStyle>
           <a:p>
             <a:r>
-              <a:rPr lang="en-US" smtClean="0"/>
+              <a:rPr lang="en-US"/>
               <a:t>Click to edit Master title style</a:t>
             </a:r>
-            <a:endParaRPr lang="en-US"/>
           </a:p>
         </p:txBody>
       </p:sp>
@@ -2496,7 +2493,7 @@
           <a:p>
             <a:pPr lvl="0"/>
             <a:r>
-              <a:rPr lang="en-US" smtClean="0"/>
+              <a:rPr lang="en-US"/>
               <a:t>Click to edit Master text styles</a:t>
             </a:r>
           </a:p>
@@ -2519,7 +2516,7 @@
           <a:p>
             <a:fld id="{5BCAD085-E8A6-8845-BD4E-CB4CCA059FC4}" type="datetimeFigureOut">
               <a:rPr lang="en-US" smtClean="0"/>
-              <a:t>1/27/13</a:t>
+              <a:t>9/29/26</a:t>
             </a:fld>
             <a:endParaRPr lang="en-US"/>
           </a:p>
@@ -2628,10 +2625,9 @@
           <a:lstStyle/>
           <a:p>
             <a:r>
-              <a:rPr lang="en-US" smtClean="0"/>
+              <a:rPr lang="en-US"/>
               <a:t>Click to edit Master title style</a:t>
             </a:r>
-            <a:endParaRPr lang="en-US"/>
           </a:p>
         </p:txBody>
       </p:sp>
@@ -2662,38 +2658,37 @@
           <a:p>
             <a:pPr lvl="0"/>
             <a:r>
-              <a:rPr lang="en-US" smtClean="0"/>
+              <a:rPr lang="en-US"/>
               <a:t>Click to edit Master text styles</a:t>
             </a:r>
           </a:p>
           <a:p>
             <a:pPr lvl="1"/>
             <a:r>
-              <a:rPr lang="en-US" smtClean="0"/>
+              <a:rPr lang="en-US"/>
               <a:t>Second level</a:t>
             </a:r>
           </a:p>
           <a:p>
             <a:pPr lvl="2"/>
             <a:r>
-              <a:rPr lang="en-US" smtClean="0"/>
+              <a:rPr lang="en-US"/>
               <a:t>Third level</a:t>
             </a:r>
           </a:p>
           <a:p>
             <a:pPr lvl="3"/>
             <a:r>
-              <a:rPr lang="en-US" smtClean="0"/>
+              <a:rPr lang="en-US"/>
               <a:t>Fourth level</a:t>
             </a:r>
           </a:p>
           <a:p>
             <a:pPr lvl="4"/>
             <a:r>
-              <a:rPr lang="en-US" smtClean="0"/>
+              <a:rPr lang="en-US"/>
               <a:t>Fifth level</a:t>
             </a:r>
-            <a:endParaRPr lang="en-US"/>
           </a:p>
         </p:txBody>
       </p:sp>
@@ -2732,7 +2727,7 @@
           <a:p>
             <a:fld id="{5BCAD085-E8A6-8845-BD4E-CB4CCA059FC4}" type="datetimeFigureOut">
               <a:rPr lang="en-US" smtClean="0"/>
-              <a:t>1/27/13</a:t>
+              <a:t>9/29/26</a:t>
             </a:fld>
             <a:endParaRPr lang="en-US"/>
           </a:p>
@@ -3091,7 +3086,7 @@
 </file>
 
 <file path=ppt/slides/slide1.xml><?xml version="1.0" encoding="utf-8"?>
-<p:sld xmlns:a="http://schemas.openxmlformats.org/drawingml/2006/main" xmlns:p="http://schemas.openxmlformats.org/presentationml/2006/main" xmlns:r="http://schemas.openxmlformats.org/officeDocument/2006/relationships">
+<p:sld xmlns:a="http://schemas.openxmlformats.org/drawingml/2006/main" xmlns:r="http://schemas.openxmlformats.org/officeDocument/2006/relationships" xmlns:p="http://schemas.openxmlformats.org/presentationml/2006/main">
   <p:cSld>
     <p:spTree>
       <p:nvGrpSpPr>
@@ -3099,7 +3094,14 @@
         <p:cNvGrpSpPr/>
         <p:nvPr/>
       </p:nvGrpSpPr>
-      <p:grpSpPr/>
+      <p:grpSpPr>
+        <a:xfrm>
+          <a:off x="0" y="0"/>
+          <a:ext cx="0" cy="0"/>
+          <a:chOff x="0" y="0"/>
+          <a:chExt cx="0" cy="0"/>
+        </a:xfrm>
+      </p:grpSpPr>
       <p:sp>
         <p:nvSpPr>
           <p:cNvPr id="2" name="Rectangle 1"/>
@@ -3140,6 +3142,7 @@
           <a:lstStyle/>
           <a:p>
             <a:pPr algn="ctr"/>
+            <a:endParaRPr/>
           </a:p>
         </p:txBody>
       </p:sp>
@@ -3152,7 +3155,7 @@
         <p:spPr>
           <a:xfrm>
             <a:off x="731520" y="502920"/>
-            <a:ext cx="10728655" cy="1828800"/>
+            <a:ext cx="10728655" cy="1346522"/>
           </a:xfrm>
           <a:prstGeom prst="rect">
             <a:avLst/>
@@ -3176,8 +3179,10 @@
               </a:defRPr>
             </a:pPr>
             <a:r>
-              <a:t>ACADEMIC CAPSTONE PROJECT REPORT PRESENTATION</a:t>
-            </a:r>
+              <a:rPr lang="en-US" dirty="0"/>
+              <a:t>Full-Stack Mini Project</a:t>
+            </a:r>
+            <a:endParaRPr dirty="0"/>
           </a:p>
           <a:p>
             <a:pPr>
@@ -3191,6 +3196,7 @@
               </a:defRPr>
             </a:pPr>
             <a:r>
+              <a:rPr dirty="0"/>
               <a:t>Career Graph</a:t>
             </a:r>
           </a:p>
@@ -3203,6 +3209,7 @@
               </a:defRPr>
             </a:pPr>
             <a:r>
+              <a:rPr dirty="0"/>
               <a:t>Interactive &amp; Personalized IT Career Roadmap Platform with Topological Prerequisite Locking and Skill Verification</a:t>
             </a:r>
           </a:p>
@@ -3250,6 +3257,7 @@
           <a:lstStyle/>
           <a:p>
             <a:pPr algn="ctr"/>
+            <a:endParaRPr/>
           </a:p>
         </p:txBody>
       </p:sp>
@@ -3262,7 +3270,7 @@
         <p:spPr>
           <a:xfrm>
             <a:off x="1005840" y="2697480"/>
-            <a:ext cx="10180015" cy="3566160"/>
+            <a:ext cx="10180015" cy="2564805"/>
           </a:xfrm>
           <a:prstGeom prst="rect">
             <a:avLst/>
@@ -3286,6 +3294,7 @@
               </a:defRPr>
             </a:pPr>
             <a:r>
+              <a:rPr dirty="0"/>
               <a:t>CAPSTONE PROJECT REPORT  •  GROUP NO. 06</a:t>
             </a:r>
           </a:p>
@@ -3301,8 +3310,30 @@
               </a:defRPr>
             </a:pPr>
             <a:r>
-              <a:t>Department of Computer Engineering / Information Technology  •  Academic Year: 2025 – 2026</a:t>
-            </a:r>
+              <a:rPr dirty="0"/>
+              <a:t>Department of Computer</a:t>
+            </a:r>
+            <a:r>
+              <a:rPr lang="en-US" dirty="0"/>
+              <a:t> Science</a:t>
+            </a:r>
+            <a:r>
+              <a:rPr dirty="0"/>
+              <a:t>  •  Academic Year: 202</a:t>
+            </a:r>
+            <a:r>
+              <a:rPr lang="en-US" dirty="0"/>
+              <a:t>6</a:t>
+            </a:r>
+            <a:r>
+              <a:rPr dirty="0"/>
+              <a:t> – 202</a:t>
+            </a:r>
+            <a:r>
+              <a:rPr lang="en-US" dirty="0"/>
+              <a:t>7</a:t>
+            </a:r>
+            <a:endParaRPr dirty="0"/>
           </a:p>
           <a:p>
             <a:pPr>
@@ -3316,7 +3347,16 @@
               </a:defRPr>
             </a:pPr>
             <a:r>
-              <a:t>1. Shinde Piyush Anil                     4. Tumma Varsha Chandraprakash</a:t>
+              <a:rPr dirty="0"/>
+              <a:t>1. Shinde Piyush Anil                     4. </a:t>
+            </a:r>
+            <a:r>
+              <a:rPr dirty="0" err="1"/>
+              <a:t>Tumma</a:t>
+            </a:r>
+            <a:r>
+              <a:rPr dirty="0"/>
+              <a:t> Varsha Chandraprakash</a:t>
             </a:r>
           </a:p>
           <a:p>
@@ -3331,6 +3371,7 @@
               </a:defRPr>
             </a:pPr>
             <a:r>
+              <a:rPr dirty="0"/>
               <a:t>2. Surve Archit Milind                    5. Vichare Sanika Sanjay</a:t>
             </a:r>
           </a:p>
@@ -3346,8 +3387,39 @@
               </a:defRPr>
             </a:pPr>
             <a:r>
-              <a:t>3. Telore Jagruti Kishore                 6. Waychal Sanyukta Amol</a:t>
-            </a:r>
+              <a:rPr dirty="0"/>
+              <a:t>3. </a:t>
+            </a:r>
+            <a:r>
+              <a:rPr dirty="0" err="1"/>
+              <a:t>Telore</a:t>
+            </a:r>
+            <a:r>
+              <a:rPr dirty="0"/>
+              <a:t> Jagruti Kishore                 6. </a:t>
+            </a:r>
+            <a:r>
+              <a:rPr dirty="0" err="1"/>
+              <a:t>Waychal</a:t>
+            </a:r>
+            <a:r>
+              <a:rPr dirty="0"/>
+              <a:t> Sanyukta Amol</a:t>
+            </a:r>
+            <a:endParaRPr lang="en-US" dirty="0"/>
+          </a:p>
+          <a:p>
+            <a:pPr>
+              <a:spcAft>
+                <a:spcPts val="1000"/>
+              </a:spcAft>
+              <a:defRPr sz="1400" b="1">
+                <a:solidFill>
+                  <a:srgbClr val="0F172A"/>
+                </a:solidFill>
+              </a:defRPr>
+            </a:pPr>
+            <a:endParaRPr dirty="0"/>
           </a:p>
           <a:p>
             <a:pPr>
@@ -3361,6 +3433,7 @@
               </a:defRPr>
             </a:pPr>
             <a:r>
+              <a:rPr sz="1400" dirty="0"/>
               <a:t>Architecture: Vue 3 Single Page App  |  Node.js &amp; Express REST API  |  MongoDB Atlas Cloud</a:t>
             </a:r>
           </a:p>
@@ -3372,9 +3445,7 @@
                 </a:solidFill>
               </a:defRPr>
             </a:pPr>
-            <a:r>
-              <a:t>Key Innovations: Topological Prerequisite Gating  •  Universal Cross-Track Credit  •  Server-Graded Proof-of-Skill</a:t>
-            </a:r>
+            <a:endParaRPr dirty="0"/>
           </a:p>
         </p:txBody>
       </p:sp>
@@ -3387,7 +3458,7 @@
 </file>
 
 <file path=ppt/slides/slide10.xml><?xml version="1.0" encoding="utf-8"?>
-<p:sld xmlns:a="http://schemas.openxmlformats.org/drawingml/2006/main" xmlns:p="http://schemas.openxmlformats.org/presentationml/2006/main" xmlns:r="http://schemas.openxmlformats.org/officeDocument/2006/relationships">
+<p:sld xmlns:a="http://schemas.openxmlformats.org/drawingml/2006/main" xmlns:r="http://schemas.openxmlformats.org/officeDocument/2006/relationships" xmlns:p="http://schemas.openxmlformats.org/presentationml/2006/main">
   <p:cSld>
     <p:spTree>
       <p:nvGrpSpPr>
@@ -3395,7 +3466,14 @@
         <p:cNvGrpSpPr/>
         <p:nvPr/>
       </p:nvGrpSpPr>
-      <p:grpSpPr/>
+      <p:grpSpPr>
+        <a:xfrm>
+          <a:off x="0" y="0"/>
+          <a:ext cx="0" cy="0"/>
+          <a:chOff x="0" y="0"/>
+          <a:chExt cx="0" cy="0"/>
+        </a:xfrm>
+      </p:grpSpPr>
       <p:sp>
         <p:nvSpPr>
           <p:cNvPr id="2" name="TextBox 1"/>
@@ -3508,6 +3586,7 @@
           <a:lstStyle/>
           <a:p>
             <a:pPr algn="ctr"/>
+            <a:endParaRPr/>
           </a:p>
         </p:txBody>
       </p:sp>
@@ -3520,7 +3599,7 @@
         <p:spPr>
           <a:xfrm>
             <a:off x="731520" y="6446520"/>
-            <a:ext cx="10728655" cy="274320"/>
+            <a:ext cx="4732065" cy="153888"/>
           </a:xfrm>
           <a:prstGeom prst="rect">
             <a:avLst/>
@@ -3541,7 +3620,8 @@
               </a:defRPr>
             </a:pPr>
             <a:r>
-              <a:t>Career Graph — Project Presentation  |  Group No. 06  |  Department of Computer Engineering / IT</a:t>
+              <a:rPr lang="en-IN" dirty="0"/>
+              <a:t>Career Graph — Project Presentation  |  Group No. 06  |  Department of Computer Science</a:t>
             </a:r>
           </a:p>
         </p:txBody>
@@ -3588,6 +3668,7 @@
           <a:lstStyle/>
           <a:p>
             <a:pPr algn="ctr"/>
+            <a:endParaRPr/>
           </a:p>
         </p:txBody>
       </p:sp>
@@ -3701,6 +3782,7 @@
           <a:lstStyle/>
           <a:p>
             <a:pPr algn="ctr"/>
+            <a:endParaRPr/>
           </a:p>
         </p:txBody>
       </p:sp>
@@ -3814,6 +3896,7 @@
           <a:lstStyle/>
           <a:p>
             <a:pPr algn="ctr"/>
+            <a:endParaRPr/>
           </a:p>
         </p:txBody>
       </p:sp>
@@ -3927,6 +4010,7 @@
           <a:lstStyle/>
           <a:p>
             <a:pPr algn="ctr"/>
+            <a:endParaRPr/>
           </a:p>
         </p:txBody>
       </p:sp>
@@ -4007,7 +4091,7 @@
 </file>
 
 <file path=ppt/slides/slide11.xml><?xml version="1.0" encoding="utf-8"?>
-<p:sld xmlns:a="http://schemas.openxmlformats.org/drawingml/2006/main" xmlns:p="http://schemas.openxmlformats.org/presentationml/2006/main" xmlns:r="http://schemas.openxmlformats.org/officeDocument/2006/relationships">
+<p:sld xmlns:a="http://schemas.openxmlformats.org/drawingml/2006/main" xmlns:r="http://schemas.openxmlformats.org/officeDocument/2006/relationships" xmlns:p="http://schemas.openxmlformats.org/presentationml/2006/main">
   <p:cSld>
     <p:spTree>
       <p:nvGrpSpPr>
@@ -4015,7 +4099,14 @@
         <p:cNvGrpSpPr/>
         <p:nvPr/>
       </p:nvGrpSpPr>
-      <p:grpSpPr/>
+      <p:grpSpPr>
+        <a:xfrm>
+          <a:off x="0" y="0"/>
+          <a:ext cx="0" cy="0"/>
+          <a:chOff x="0" y="0"/>
+          <a:chExt cx="0" cy="0"/>
+        </a:xfrm>
+      </p:grpSpPr>
       <p:sp>
         <p:nvSpPr>
           <p:cNvPr id="2" name="TextBox 1"/>
@@ -4128,6 +4219,7 @@
           <a:lstStyle/>
           <a:p>
             <a:pPr algn="ctr"/>
+            <a:endParaRPr/>
           </a:p>
         </p:txBody>
       </p:sp>
@@ -4140,7 +4232,7 @@
         <p:spPr>
           <a:xfrm>
             <a:off x="731520" y="6446520"/>
-            <a:ext cx="10728655" cy="274320"/>
+            <a:ext cx="4732065" cy="153888"/>
           </a:xfrm>
           <a:prstGeom prst="rect">
             <a:avLst/>
@@ -4161,7 +4253,8 @@
               </a:defRPr>
             </a:pPr>
             <a:r>
-              <a:t>Career Graph — Project Presentation  |  Group No. 06  |  Department of Computer Engineering / IT</a:t>
+              <a:rPr lang="en-IN" dirty="0"/>
+              <a:t>Career Graph — Project Presentation  |  Group No. 06  |  Department of Computer Science</a:t>
             </a:r>
           </a:p>
         </p:txBody>
@@ -4208,6 +4301,7 @@
           <a:lstStyle/>
           <a:p>
             <a:pPr algn="ctr"/>
+            <a:endParaRPr/>
           </a:p>
         </p:txBody>
       </p:sp>
@@ -4220,7 +4314,7 @@
         <p:spPr>
           <a:xfrm>
             <a:off x="960120" y="1481328"/>
-            <a:ext cx="4754880" cy="4617720"/>
+            <a:ext cx="4754880" cy="4172937"/>
           </a:xfrm>
           <a:prstGeom prst="rect">
             <a:avLst/>
@@ -4244,6 +4338,7 @@
               </a:defRPr>
             </a:pPr>
             <a:r>
+              <a:rPr dirty="0"/>
               <a:t>Advantages &amp; Key Strengths</a:t>
             </a:r>
           </a:p>
@@ -4259,18 +4354,20 @@
               </a:defRPr>
             </a:pPr>
             <a:r>
+              <a:rPr dirty="0"/>
               <a:t>Architectural &amp; Pedagogical Superiority</a:t>
             </a:r>
           </a:p>
           <a:p>
             <a:pPr>
-              <a:defRPr b="1" sz="1300">
+              <a:defRPr sz="1300" b="1">
                 <a:solidFill>
                   <a:srgbClr val="1E3A8A"/>
                 </a:solidFill>
               </a:defRPr>
             </a:pPr>
             <a:r>
+              <a:rPr dirty="0"/>
               <a:t>✓ Enforced Prerequisite Sequencing</a:t>
             </a:r>
           </a:p>
@@ -4286,18 +4383,20 @@
               </a:defRPr>
             </a:pPr>
             <a:r>
+              <a:rPr dirty="0"/>
               <a:t>   Mathematical topological gating prevents students from skipping fundamental syntax to rush into advanced frameworks, directly combating course abandonment.</a:t>
             </a:r>
           </a:p>
           <a:p>
             <a:pPr>
-              <a:defRPr b="1" sz="1300">
+              <a:defRPr sz="1300" b="1">
                 <a:solidFill>
                   <a:srgbClr val="1E3A8A"/>
                 </a:solidFill>
               </a:defRPr>
             </a:pPr>
             <a:r>
+              <a:rPr dirty="0"/>
               <a:t>✓ Universal Cross-Track Mobility</a:t>
             </a:r>
           </a:p>
@@ -4313,18 +4412,20 @@
               </a:defRPr>
             </a:pPr>
             <a:r>
+              <a:rPr dirty="0"/>
               <a:t>   Competencies mastered in one track (e.g. Git, Python, SQL) carry over immediately when switching tracks, saving dozens of hours of duplicate study.</a:t>
             </a:r>
           </a:p>
           <a:p>
             <a:pPr>
-              <a:defRPr b="1" sz="1300">
+              <a:defRPr sz="1300" b="1">
                 <a:solidFill>
                   <a:srgbClr val="1E3A8A"/>
                 </a:solidFill>
               </a:defRPr>
             </a:pPr>
             <a:r>
+              <a:rPr dirty="0"/>
               <a:t>✓ Tamper-Proof Proof-of-Skill</a:t>
             </a:r>
           </a:p>
@@ -4340,18 +4441,20 @@
               </a:defRPr>
             </a:pPr>
             <a:r>
+              <a:rPr dirty="0"/>
               <a:t>   Server-graded micro-quizzes with client payload sanitization eliminate honor-system cheating and award credible, verifiable badges (🛡️).</a:t>
             </a:r>
           </a:p>
           <a:p>
             <a:pPr>
-              <a:defRPr b="1" sz="1300">
+              <a:defRPr sz="1300" b="1">
                 <a:solidFill>
                   <a:srgbClr val="1E3A8A"/>
                 </a:solidFill>
               </a:defRPr>
             </a:pPr>
             <a:r>
+              <a:rPr dirty="0"/>
               <a:t>✓ Non-Disruptive Dynamic Navigation</a:t>
             </a:r>
           </a:p>
@@ -4367,18 +4470,20 @@
               </a:defRPr>
             </a:pPr>
             <a:r>
+              <a:rPr dirty="0"/>
               <a:t>   In-canvas slide-out drawers and instant status toggling maintain learner focus without continuous page reloads or context loss.</a:t>
             </a:r>
           </a:p>
           <a:p>
             <a:pPr>
-              <a:defRPr b="1" sz="1300">
+              <a:defRPr sz="1300" b="1">
                 <a:solidFill>
                   <a:srgbClr val="1E3A8A"/>
                 </a:solidFill>
               </a:defRPr>
             </a:pPr>
             <a:r>
+              <a:rPr dirty="0"/>
               <a:t>✓ Production-Ready Decoupled Stack</a:t>
             </a:r>
           </a:p>
@@ -4394,6 +4499,7 @@
               </a:defRPr>
             </a:pPr>
             <a:r>
+              <a:rPr dirty="0"/>
               <a:t>   Modern Vue 3 SPA + Node/Express REST API delivers sub-100ms UI response times, modular maintenance, and horizontal cloud scalability.</a:t>
             </a:r>
           </a:p>
@@ -4441,6 +4547,7 @@
           <a:lstStyle/>
           <a:p>
             <a:pPr algn="ctr"/>
+            <a:endParaRPr/>
           </a:p>
         </p:txBody>
       </p:sp>
@@ -4453,7 +4560,7 @@
         <p:spPr>
           <a:xfrm>
             <a:off x="6446520" y="1481328"/>
-            <a:ext cx="4754880" cy="4617720"/>
+            <a:ext cx="4754880" cy="4172937"/>
           </a:xfrm>
           <a:prstGeom prst="rect">
             <a:avLst/>
@@ -4477,6 +4584,7 @@
               </a:defRPr>
             </a:pPr>
             <a:r>
+              <a:rPr dirty="0"/>
               <a:t>Limitations &amp; Disadvantages</a:t>
             </a:r>
           </a:p>
@@ -4492,18 +4600,20 @@
               </a:defRPr>
             </a:pPr>
             <a:r>
+              <a:rPr dirty="0"/>
               <a:t>Realistic Engineering Constraints</a:t>
             </a:r>
           </a:p>
           <a:p>
             <a:pPr>
-              <a:defRPr b="1" sz="1300">
+              <a:defRPr sz="1300" b="1">
                 <a:solidFill>
                   <a:srgbClr val="B45309"/>
                 </a:solidFill>
               </a:defRPr>
             </a:pPr>
             <a:r>
+              <a:rPr dirty="0"/>
               <a:t>• Initial Curriculum Scope</a:t>
             </a:r>
           </a:p>
@@ -4519,18 +4629,20 @@
               </a:defRPr>
             </a:pPr>
             <a:r>
+              <a:rPr dirty="0"/>
               <a:t>   Currently covers 6 high-demand IT tracks (Full Stack, DevOps, AI, Cloud, Data, Cyber); emerging niche fields require ongoing administrator curation.</a:t>
             </a:r>
           </a:p>
           <a:p>
             <a:pPr>
-              <a:defRPr b="1" sz="1300">
+              <a:defRPr sz="1300" b="1">
                 <a:solidFill>
                   <a:srgbClr val="B45309"/>
                 </a:solidFill>
               </a:defRPr>
             </a:pPr>
             <a:r>
+              <a:rPr dirty="0"/>
               <a:t>• Fixed Validation Quiz Pool</a:t>
             </a:r>
           </a:p>
@@ -4546,18 +4658,20 @@
               </a:defRPr>
             </a:pPr>
             <a:r>
+              <a:rPr dirty="0"/>
               <a:t>   Each skill currently draws from a curated 3-question evaluation pool; future expansion requires randomized question banks to prevent repeat memorization.</a:t>
             </a:r>
           </a:p>
           <a:p>
             <a:pPr>
-              <a:defRPr b="1" sz="1300">
+              <a:defRPr sz="1300" b="1">
                 <a:solidFill>
                   <a:srgbClr val="B45309"/>
                 </a:solidFill>
               </a:defRPr>
             </a:pPr>
             <a:r>
+              <a:rPr dirty="0"/>
               <a:t>• Active Network Dependency</a:t>
             </a:r>
           </a:p>
@@ -4573,18 +4687,20 @@
               </a:defRPr>
             </a:pPr>
             <a:r>
+              <a:rPr dirty="0"/>
               <a:t>   Real-time progress synchronization and server-side quiz grading require active internet connectivity, lacking offline-first PWA caching.</a:t>
             </a:r>
           </a:p>
           <a:p>
             <a:pPr>
-              <a:defRPr b="1" sz="1300">
+              <a:defRPr sz="1300" b="1">
                 <a:solidFill>
                   <a:srgbClr val="B45309"/>
                 </a:solidFill>
               </a:defRPr>
             </a:pPr>
             <a:r>
+              <a:rPr dirty="0"/>
               <a:t>• Absence of In-Browser Code Sandbox</a:t>
             </a:r>
           </a:p>
@@ -4600,18 +4716,28 @@
               </a:defRPr>
             </a:pPr>
             <a:r>
-              <a:t>   Assesses conceptual and architectural understanding through quizzes, but does not yet compile and execute student code in an isolated WebAssembly sandbox.</a:t>
-            </a:r>
-          </a:p>
-          <a:p>
-            <a:pPr>
-              <a:defRPr b="1" sz="1300">
+              <a:rPr dirty="0"/>
+              <a:t>   Assesses conceptual and architectural understanding through quizzes, but does not yet compile and execute student code in an isolated </a:t>
+            </a:r>
+            <a:r>
+              <a:rPr dirty="0" err="1"/>
+              <a:t>WebAssembly</a:t>
+            </a:r>
+            <a:r>
+              <a:rPr dirty="0"/>
+              <a:t> sandbox.</a:t>
+            </a:r>
+          </a:p>
+          <a:p>
+            <a:pPr>
+              <a:defRPr sz="1300" b="1">
                 <a:solidFill>
                   <a:srgbClr val="B45309"/>
                 </a:solidFill>
               </a:defRPr>
             </a:pPr>
             <a:r>
+              <a:rPr dirty="0"/>
               <a:t>• Subjective Initial Onboarding</a:t>
             </a:r>
           </a:p>
@@ -4627,6 +4753,7 @@
               </a:defRPr>
             </a:pPr>
             <a:r>
+              <a:rPr dirty="0"/>
               <a:t>   Initial baseline self-ratings rely on student honesty upon sign-up until objectively validated through subsequent micro-quizzes.</a:t>
             </a:r>
           </a:p>
@@ -4641,7 +4768,7 @@
 </file>
 
 <file path=ppt/slides/slide12.xml><?xml version="1.0" encoding="utf-8"?>
-<p:sld xmlns:a="http://schemas.openxmlformats.org/drawingml/2006/main" xmlns:p="http://schemas.openxmlformats.org/presentationml/2006/main" xmlns:r="http://schemas.openxmlformats.org/officeDocument/2006/relationships">
+<p:sld xmlns:a="http://schemas.openxmlformats.org/drawingml/2006/main" xmlns:r="http://schemas.openxmlformats.org/officeDocument/2006/relationships" xmlns:p="http://schemas.openxmlformats.org/presentationml/2006/main">
   <p:cSld>
     <p:spTree>
       <p:nvGrpSpPr>
@@ -4649,7 +4776,14 @@
         <p:cNvGrpSpPr/>
         <p:nvPr/>
       </p:nvGrpSpPr>
-      <p:grpSpPr/>
+      <p:grpSpPr>
+        <a:xfrm>
+          <a:off x="0" y="0"/>
+          <a:ext cx="0" cy="0"/>
+          <a:chOff x="0" y="0"/>
+          <a:chExt cx="0" cy="0"/>
+        </a:xfrm>
+      </p:grpSpPr>
       <p:sp>
         <p:nvSpPr>
           <p:cNvPr id="2" name="TextBox 1"/>
@@ -4762,6 +4896,7 @@
           <a:lstStyle/>
           <a:p>
             <a:pPr algn="ctr"/>
+            <a:endParaRPr/>
           </a:p>
         </p:txBody>
       </p:sp>
@@ -4774,7 +4909,7 @@
         <p:spPr>
           <a:xfrm>
             <a:off x="731520" y="6446520"/>
-            <a:ext cx="10728655" cy="274320"/>
+            <a:ext cx="4732065" cy="153888"/>
           </a:xfrm>
           <a:prstGeom prst="rect">
             <a:avLst/>
@@ -4795,7 +4930,8 @@
               </a:defRPr>
             </a:pPr>
             <a:r>
-              <a:t>Career Graph — Project Presentation  |  Group No. 06  |  Department of Computer Engineering / IT</a:t>
+              <a:rPr lang="en-IN" dirty="0"/>
+              <a:t>Career Graph — Project Presentation  |  Group No. 06  |  Department of Computer Science</a:t>
             </a:r>
           </a:p>
         </p:txBody>
@@ -4842,6 +4978,7 @@
           <a:lstStyle/>
           <a:p>
             <a:pPr algn="ctr"/>
+            <a:endParaRPr/>
           </a:p>
         </p:txBody>
       </p:sp>
@@ -4997,6 +5134,7 @@
           <a:lstStyle/>
           <a:p>
             <a:pPr algn="ctr"/>
+            <a:endParaRPr/>
           </a:p>
         </p:txBody>
       </p:sp>
@@ -5152,6 +5290,7 @@
           <a:lstStyle/>
           <a:p>
             <a:pPr algn="ctr"/>
+            <a:endParaRPr/>
           </a:p>
         </p:txBody>
       </p:sp>
@@ -5274,7 +5413,7 @@
 </file>
 
 <file path=ppt/slides/slide13.xml><?xml version="1.0" encoding="utf-8"?>
-<p:sld xmlns:a="http://schemas.openxmlformats.org/drawingml/2006/main" xmlns:p="http://schemas.openxmlformats.org/presentationml/2006/main" xmlns:r="http://schemas.openxmlformats.org/officeDocument/2006/relationships">
+<p:sld xmlns:a="http://schemas.openxmlformats.org/drawingml/2006/main" xmlns:r="http://schemas.openxmlformats.org/officeDocument/2006/relationships" xmlns:p="http://schemas.openxmlformats.org/presentationml/2006/main">
   <p:cSld>
     <p:spTree>
       <p:nvGrpSpPr>
@@ -5282,7 +5421,14 @@
         <p:cNvGrpSpPr/>
         <p:nvPr/>
       </p:nvGrpSpPr>
-      <p:grpSpPr/>
+      <p:grpSpPr>
+        <a:xfrm>
+          <a:off x="0" y="0"/>
+          <a:ext cx="0" cy="0"/>
+          <a:chOff x="0" y="0"/>
+          <a:chExt cx="0" cy="0"/>
+        </a:xfrm>
+      </p:grpSpPr>
       <p:sp>
         <p:nvSpPr>
           <p:cNvPr id="2" name="TextBox 1"/>
@@ -5395,6 +5541,7 @@
           <a:lstStyle/>
           <a:p>
             <a:pPr algn="ctr"/>
+            <a:endParaRPr/>
           </a:p>
         </p:txBody>
       </p:sp>
@@ -5407,7 +5554,7 @@
         <p:spPr>
           <a:xfrm>
             <a:off x="731520" y="6446520"/>
-            <a:ext cx="10728655" cy="274320"/>
+            <a:ext cx="4732065" cy="153888"/>
           </a:xfrm>
           <a:prstGeom prst="rect">
             <a:avLst/>
@@ -5428,7 +5575,8 @@
               </a:defRPr>
             </a:pPr>
             <a:r>
-              <a:t>Career Graph — Project Presentation  |  Group No. 06  |  Department of Computer Engineering / IT</a:t>
+              <a:rPr lang="en-IN" dirty="0"/>
+              <a:t>Career Graph — Project Presentation  |  Group No. 06  |  Department of Computer Science</a:t>
             </a:r>
           </a:p>
         </p:txBody>
@@ -5475,6 +5623,7 @@
           <a:lstStyle/>
           <a:p>
             <a:pPr algn="ctr"/>
+            <a:endParaRPr/>
           </a:p>
         </p:txBody>
       </p:sp>
@@ -5504,7 +5653,7 @@
               <a:spcAft>
                 <a:spcPts val="300"/>
               </a:spcAft>
-              <a:defRPr b="1" sz="1700">
+              <a:defRPr sz="1700" b="1">
                 <a:solidFill>
                   <a:srgbClr val="1E3A8A"/>
                 </a:solidFill>
@@ -5531,7 +5680,7 @@
           </a:p>
           <a:p>
             <a:pPr>
-              <a:defRPr b="1" sz="1300">
+              <a:defRPr sz="1300" b="1">
                 <a:solidFill>
                   <a:srgbClr val="0F172A"/>
                 </a:solidFill>
@@ -5558,7 +5707,7 @@
           </a:p>
           <a:p>
             <a:pPr>
-              <a:defRPr b="1" sz="1300">
+              <a:defRPr sz="1300" b="1">
                 <a:solidFill>
                   <a:srgbClr val="0F172A"/>
                 </a:solidFill>
@@ -5585,7 +5734,7 @@
           </a:p>
           <a:p>
             <a:pPr>
-              <a:defRPr b="1" sz="1300">
+              <a:defRPr sz="1300" b="1">
                 <a:solidFill>
                   <a:srgbClr val="0F172A"/>
                 </a:solidFill>
@@ -5612,7 +5761,7 @@
           </a:p>
           <a:p>
             <a:pPr>
-              <a:defRPr b="1" sz="1300">
+              <a:defRPr sz="1300" b="1">
                 <a:solidFill>
                   <a:srgbClr val="0F172A"/>
                 </a:solidFill>
@@ -5681,6 +5830,7 @@
           <a:lstStyle/>
           <a:p>
             <a:pPr algn="ctr"/>
+            <a:endParaRPr/>
           </a:p>
         </p:txBody>
       </p:sp>
@@ -5710,7 +5860,7 @@
               <a:spcAft>
                 <a:spcPts val="300"/>
               </a:spcAft>
-              <a:defRPr b="1" sz="1700">
+              <a:defRPr sz="1700" b="1">
                 <a:solidFill>
                   <a:srgbClr val="1E3A8A"/>
                 </a:solidFill>
@@ -5737,7 +5887,7 @@
           </a:p>
           <a:p>
             <a:pPr>
-              <a:defRPr b="1" sz="1300">
+              <a:defRPr sz="1300" b="1">
                 <a:solidFill>
                   <a:srgbClr val="0F172A"/>
                 </a:solidFill>
@@ -5764,7 +5914,7 @@
           </a:p>
           <a:p>
             <a:pPr>
-              <a:defRPr b="1" sz="1300">
+              <a:defRPr sz="1300" b="1">
                 <a:solidFill>
                   <a:srgbClr val="0F172A"/>
                 </a:solidFill>
@@ -5791,7 +5941,7 @@
           </a:p>
           <a:p>
             <a:pPr>
-              <a:defRPr b="1" sz="1300">
+              <a:defRPr sz="1300" b="1">
                 <a:solidFill>
                   <a:srgbClr val="0F172A"/>
                 </a:solidFill>
@@ -5818,7 +5968,7 @@
           </a:p>
           <a:p>
             <a:pPr>
-              <a:defRPr b="1" sz="1300">
+              <a:defRPr sz="1300" b="1">
                 <a:solidFill>
                   <a:srgbClr val="0F172A"/>
                 </a:solidFill>
@@ -5887,6 +6037,7 @@
           <a:lstStyle/>
           <a:p>
             <a:pPr algn="ctr"/>
+            <a:endParaRPr/>
           </a:p>
         </p:txBody>
       </p:sp>
@@ -5916,7 +6067,7 @@
               <a:spcAft>
                 <a:spcPts val="200"/>
               </a:spcAft>
-              <a:defRPr b="1" sz="1500">
+              <a:defRPr sz="1500" b="1">
                 <a:solidFill>
                   <a:srgbClr val="FFFFFF"/>
                 </a:solidFill>
@@ -5949,7 +6100,7 @@
 </file>
 
 <file path=ppt/slides/slide2.xml><?xml version="1.0" encoding="utf-8"?>
-<p:sld xmlns:a="http://schemas.openxmlformats.org/drawingml/2006/main" xmlns:p="http://schemas.openxmlformats.org/presentationml/2006/main" xmlns:r="http://schemas.openxmlformats.org/officeDocument/2006/relationships">
+<p:sld xmlns:a="http://schemas.openxmlformats.org/drawingml/2006/main" xmlns:r="http://schemas.openxmlformats.org/officeDocument/2006/relationships" xmlns:p="http://schemas.openxmlformats.org/presentationml/2006/main">
   <p:cSld>
     <p:spTree>
       <p:nvGrpSpPr>
@@ -5957,7 +6108,14 @@
         <p:cNvGrpSpPr/>
         <p:nvPr/>
       </p:nvGrpSpPr>
-      <p:grpSpPr/>
+      <p:grpSpPr>
+        <a:xfrm>
+          <a:off x="0" y="0"/>
+          <a:ext cx="0" cy="0"/>
+          <a:chOff x="0" y="0"/>
+          <a:chExt cx="0" cy="0"/>
+        </a:xfrm>
+      </p:grpSpPr>
       <p:sp>
         <p:nvSpPr>
           <p:cNvPr id="2" name="TextBox 1"/>
@@ -6070,6 +6228,7 @@
           <a:lstStyle/>
           <a:p>
             <a:pPr algn="ctr"/>
+            <a:endParaRPr/>
           </a:p>
         </p:txBody>
       </p:sp>
@@ -6082,7 +6241,7 @@
         <p:spPr>
           <a:xfrm>
             <a:off x="731520" y="6446520"/>
-            <a:ext cx="10728655" cy="274320"/>
+            <a:ext cx="4732065" cy="153888"/>
           </a:xfrm>
           <a:prstGeom prst="rect">
             <a:avLst/>
@@ -6103,8 +6262,14 @@
               </a:defRPr>
             </a:pPr>
             <a:r>
-              <a:t>Career Graph — Project Presentation  |  Group No. 06  |  Department of Computer Engineering / IT</a:t>
-            </a:r>
+              <a:rPr dirty="0"/>
+              <a:t>Career Graph — Project Presentation  |  Group No. 06  |  Department of Computer </a:t>
+            </a:r>
+            <a:r>
+              <a:rPr lang="en-US" dirty="0"/>
+              <a:t>Science</a:t>
+            </a:r>
+            <a:endParaRPr dirty="0"/>
           </a:p>
         </p:txBody>
       </p:sp>
@@ -6150,6 +6315,7 @@
           <a:lstStyle/>
           <a:p>
             <a:pPr algn="ctr"/>
+            <a:endParaRPr/>
           </a:p>
         </p:txBody>
       </p:sp>
@@ -6263,6 +6429,7 @@
           <a:lstStyle/>
           <a:p>
             <a:pPr algn="ctr"/>
+            <a:endParaRPr/>
           </a:p>
         </p:txBody>
       </p:sp>
@@ -6376,6 +6543,7 @@
           <a:lstStyle/>
           <a:p>
             <a:pPr algn="ctr"/>
+            <a:endParaRPr/>
           </a:p>
         </p:txBody>
       </p:sp>
@@ -6489,6 +6657,7 @@
           <a:lstStyle/>
           <a:p>
             <a:pPr algn="ctr"/>
+            <a:endParaRPr/>
           </a:p>
         </p:txBody>
       </p:sp>
@@ -6569,7 +6738,7 @@
 </file>
 
 <file path=ppt/slides/slide3.xml><?xml version="1.0" encoding="utf-8"?>
-<p:sld xmlns:a="http://schemas.openxmlformats.org/drawingml/2006/main" xmlns:p="http://schemas.openxmlformats.org/presentationml/2006/main" xmlns:r="http://schemas.openxmlformats.org/officeDocument/2006/relationships">
+<p:sld xmlns:a="http://schemas.openxmlformats.org/drawingml/2006/main" xmlns:r="http://schemas.openxmlformats.org/officeDocument/2006/relationships" xmlns:p="http://schemas.openxmlformats.org/presentationml/2006/main">
   <p:cSld>
     <p:spTree>
       <p:nvGrpSpPr>
@@ -6577,7 +6746,14 @@
         <p:cNvGrpSpPr/>
         <p:nvPr/>
       </p:nvGrpSpPr>
-      <p:grpSpPr/>
+      <p:grpSpPr>
+        <a:xfrm>
+          <a:off x="0" y="0"/>
+          <a:ext cx="0" cy="0"/>
+          <a:chOff x="0" y="0"/>
+          <a:chExt cx="0" cy="0"/>
+        </a:xfrm>
+      </p:grpSpPr>
       <p:sp>
         <p:nvSpPr>
           <p:cNvPr id="2" name="TextBox 1"/>
@@ -6690,6 +6866,7 @@
           <a:lstStyle/>
           <a:p>
             <a:pPr algn="ctr"/>
+            <a:endParaRPr/>
           </a:p>
         </p:txBody>
       </p:sp>
@@ -6702,7 +6879,7 @@
         <p:spPr>
           <a:xfrm>
             <a:off x="731520" y="6446520"/>
-            <a:ext cx="10728655" cy="274320"/>
+            <a:ext cx="4732065" cy="153888"/>
           </a:xfrm>
           <a:prstGeom prst="rect">
             <a:avLst/>
@@ -6723,8 +6900,14 @@
               </a:defRPr>
             </a:pPr>
             <a:r>
-              <a:t>Career Graph — Project Presentation  |  Group No. 06  |  Department of Computer Engineering / IT</a:t>
-            </a:r>
+              <a:rPr dirty="0"/>
+              <a:t>Career Graph — Project Presentation  |  Group No. 06  |  Department of Computer </a:t>
+            </a:r>
+            <a:r>
+              <a:rPr lang="en-US" dirty="0"/>
+              <a:t>Science</a:t>
+            </a:r>
+            <a:endParaRPr dirty="0"/>
           </a:p>
         </p:txBody>
       </p:sp>
@@ -6770,6 +6953,7 @@
           <a:lstStyle/>
           <a:p>
             <a:pPr algn="ctr"/>
+            <a:endParaRPr/>
           </a:p>
         </p:txBody>
       </p:sp>
@@ -6826,7 +7010,7 @@
           </a:p>
           <a:p>
             <a:pPr>
-              <a:defRPr b="1" sz="1300">
+              <a:defRPr sz="1300" b="1">
                 <a:solidFill>
                   <a:srgbClr val="0F172A"/>
                 </a:solidFill>
@@ -6853,7 +7037,7 @@
           </a:p>
           <a:p>
             <a:pPr>
-              <a:defRPr b="1" sz="1300">
+              <a:defRPr sz="1300" b="1">
                 <a:solidFill>
                   <a:srgbClr val="0F172A"/>
                 </a:solidFill>
@@ -6880,7 +7064,7 @@
           </a:p>
           <a:p>
             <a:pPr>
-              <a:defRPr b="1" sz="1300">
+              <a:defRPr sz="1300" b="1">
                 <a:solidFill>
                   <a:srgbClr val="0F172A"/>
                 </a:solidFill>
@@ -6907,7 +7091,7 @@
           </a:p>
           <a:p>
             <a:pPr>
-              <a:defRPr b="1" sz="1300">
+              <a:defRPr sz="1300" b="1">
                 <a:solidFill>
                   <a:srgbClr val="0F172A"/>
                 </a:solidFill>
@@ -6934,7 +7118,7 @@
           </a:p>
           <a:p>
             <a:pPr>
-              <a:defRPr b="1" sz="1300">
+              <a:defRPr sz="1300" b="1">
                 <a:solidFill>
                   <a:srgbClr val="0F172A"/>
                 </a:solidFill>
@@ -7003,6 +7187,7 @@
           <a:lstStyle/>
           <a:p>
             <a:pPr algn="ctr"/>
+            <a:endParaRPr/>
           </a:p>
         </p:txBody>
       </p:sp>
@@ -7039,6 +7224,7 @@
               </a:defRPr>
             </a:pPr>
             <a:r>
+              <a:rPr dirty="0"/>
               <a:t>4 Core Technical Pillars</a:t>
             </a:r>
           </a:p>
@@ -7054,18 +7240,20 @@
               </a:defRPr>
             </a:pPr>
             <a:r>
+              <a:rPr dirty="0"/>
               <a:t>Platform Engineering Differentiators</a:t>
             </a:r>
           </a:p>
           <a:p>
             <a:pPr>
-              <a:defRPr b="1" sz="1300">
+              <a:defRPr sz="1300" b="1">
                 <a:solidFill>
                   <a:srgbClr val="1E3A8A"/>
                 </a:solidFill>
               </a:defRPr>
             </a:pPr>
             <a:r>
+              <a:rPr dirty="0"/>
               <a:t>✓ Topological Prerequisite Engine</a:t>
             </a:r>
           </a:p>
@@ -7081,18 +7269,20 @@
               </a:defRPr>
             </a:pPr>
             <a:r>
+              <a:rPr dirty="0"/>
               <a:t>   Advanced phases lock strictly until foundational skills reach 100% completion, eliminating premature tool hopping.</a:t>
             </a:r>
           </a:p>
           <a:p>
             <a:pPr>
-              <a:defRPr b="1" sz="1300">
+              <a:defRPr sz="1300" b="1">
                 <a:solidFill>
                   <a:srgbClr val="1E3A8A"/>
                 </a:solidFill>
               </a:defRPr>
             </a:pPr>
             <a:r>
+              <a:rPr dirty="0"/>
               <a:t>✓ Adaptive Onboarding Baseline</a:t>
             </a:r>
           </a:p>
@@ -7108,18 +7298,20 @@
               </a:defRPr>
             </a:pPr>
             <a:r>
+              <a:rPr dirty="0"/>
               <a:t>   Calibrates roadmap starting points based on student academic degree, stream, and declared baseline knowledge.</a:t>
             </a:r>
           </a:p>
           <a:p>
             <a:pPr>
-              <a:defRPr b="1" sz="1300">
+              <a:defRPr sz="1300" b="1">
                 <a:solidFill>
                   <a:srgbClr val="1E3A8A"/>
                 </a:solidFill>
               </a:defRPr>
             </a:pPr>
             <a:r>
+              <a:rPr dirty="0"/>
               <a:t>✓ Universal Cross-Track Credit</a:t>
             </a:r>
           </a:p>
@@ -7135,18 +7327,20 @@
               </a:defRPr>
             </a:pPr>
             <a:r>
+              <a:rPr dirty="0"/>
               <a:t>   Canonical skill IDs ensure skills mastered in one track immediately reflect across all adjacent tracks.</a:t>
             </a:r>
           </a:p>
           <a:p>
             <a:pPr>
-              <a:defRPr b="1" sz="1300">
+              <a:defRPr sz="1300" b="1">
                 <a:solidFill>
                   <a:srgbClr val="1E3A8A"/>
                 </a:solidFill>
               </a:defRPr>
             </a:pPr>
             <a:r>
+              <a:rPr dirty="0"/>
               <a:t>✓ Server-Graded Proof-of-Skill</a:t>
             </a:r>
           </a:p>
@@ -7162,6 +7356,7 @@
               </a:defRPr>
             </a:pPr>
             <a:r>
+              <a:rPr dirty="0"/>
               <a:t>   Tamper-proof micro-quizzes evaluate advanced phase learners and award verifiable skill badges (🛡️).</a:t>
             </a:r>
           </a:p>
@@ -7176,7 +7371,7 @@
 </file>
 
 <file path=ppt/slides/slide4.xml><?xml version="1.0" encoding="utf-8"?>
-<p:sld xmlns:a="http://schemas.openxmlformats.org/drawingml/2006/main" xmlns:p="http://schemas.openxmlformats.org/presentationml/2006/main" xmlns:r="http://schemas.openxmlformats.org/officeDocument/2006/relationships">
+<p:sld xmlns:a="http://schemas.openxmlformats.org/drawingml/2006/main" xmlns:r="http://schemas.openxmlformats.org/officeDocument/2006/relationships" xmlns:p="http://schemas.openxmlformats.org/presentationml/2006/main">
   <p:cSld>
     <p:spTree>
       <p:nvGrpSpPr>
@@ -7184,7 +7379,14 @@
         <p:cNvGrpSpPr/>
         <p:nvPr/>
       </p:nvGrpSpPr>
-      <p:grpSpPr/>
+      <p:grpSpPr>
+        <a:xfrm>
+          <a:off x="0" y="0"/>
+          <a:ext cx="0" cy="0"/>
+          <a:chOff x="0" y="0"/>
+          <a:chExt cx="0" cy="0"/>
+        </a:xfrm>
+      </p:grpSpPr>
       <p:sp>
         <p:nvSpPr>
           <p:cNvPr id="2" name="TextBox 1"/>
@@ -7297,6 +7499,7 @@
           <a:lstStyle/>
           <a:p>
             <a:pPr algn="ctr"/>
+            <a:endParaRPr/>
           </a:p>
         </p:txBody>
       </p:sp>
@@ -7309,7 +7512,7 @@
         <p:spPr>
           <a:xfrm>
             <a:off x="731520" y="6446520"/>
-            <a:ext cx="10728655" cy="274320"/>
+            <a:ext cx="4732065" cy="153888"/>
           </a:xfrm>
           <a:prstGeom prst="rect">
             <a:avLst/>
@@ -7330,8 +7533,14 @@
               </a:defRPr>
             </a:pPr>
             <a:r>
-              <a:t>Career Graph — Project Presentation  |  Group No. 06  |  Department of Computer Engineering / IT</a:t>
-            </a:r>
+              <a:rPr dirty="0"/>
+              <a:t>Career Graph — Project Presentation  |  Group No. 06  |  Department of Computer </a:t>
+            </a:r>
+            <a:r>
+              <a:rPr lang="en-US" dirty="0"/>
+              <a:t>Science</a:t>
+            </a:r>
+            <a:endParaRPr dirty="0"/>
           </a:p>
         </p:txBody>
       </p:sp>
@@ -7354,10 +7563,34 @@
                 <a:tableStyleId>{5C22544A-7EE6-4342-B048-85BDC9FD1C3A}</a:tableStyleId>
               </a:tblPr>
               <a:tblGrid>
-                <a:gridCol w="2926080"/>
-                <a:gridCol w="2377440"/>
-                <a:gridCol w="2377440"/>
-                <a:gridCol w="3047695"/>
+                <a:gridCol w="2926080">
+                  <a:extLst>
+                    <a:ext uri="{9D8B030D-6E8A-4147-A177-3AD203B41FA5}">
+                      <a16:colId xmlns:a16="http://schemas.microsoft.com/office/drawing/2014/main" val="20000"/>
+                    </a:ext>
+                  </a:extLst>
+                </a:gridCol>
+                <a:gridCol w="2377440">
+                  <a:extLst>
+                    <a:ext uri="{9D8B030D-6E8A-4147-A177-3AD203B41FA5}">
+                      <a16:colId xmlns:a16="http://schemas.microsoft.com/office/drawing/2014/main" val="20001"/>
+                    </a:ext>
+                  </a:extLst>
+                </a:gridCol>
+                <a:gridCol w="2377440">
+                  <a:extLst>
+                    <a:ext uri="{9D8B030D-6E8A-4147-A177-3AD203B41FA5}">
+                      <a16:colId xmlns:a16="http://schemas.microsoft.com/office/drawing/2014/main" val="20002"/>
+                    </a:ext>
+                  </a:extLst>
+                </a:gridCol>
+                <a:gridCol w="3047695">
+                  <a:extLst>
+                    <a:ext uri="{9D8B030D-6E8A-4147-A177-3AD203B41FA5}">
+                      <a16:colId xmlns:a16="http://schemas.microsoft.com/office/drawing/2014/main" val="20003"/>
+                    </a:ext>
+                  </a:extLst>
+                </a:gridCol>
               </a:tblGrid>
               <a:tr h="711925">
                 <a:tc>
@@ -7366,7 +7599,7 @@
                     <a:lstStyle/>
                     <a:p>
                       <a:pPr algn="ctr">
-                        <a:defRPr b="1" sz="1300">
+                        <a:defRPr sz="1300" b="1">
                           <a:solidFill>
                             <a:srgbClr val="FFFFFF"/>
                           </a:solidFill>
@@ -7389,7 +7622,7 @@
                     <a:lstStyle/>
                     <a:p>
                       <a:pPr algn="ctr">
-                        <a:defRPr b="1" sz="1300">
+                        <a:defRPr sz="1300" b="1">
                           <a:solidFill>
                             <a:srgbClr val="FFFFFF"/>
                           </a:solidFill>
@@ -7412,7 +7645,7 @@
                     <a:lstStyle/>
                     <a:p>
                       <a:pPr algn="ctr">
-                        <a:defRPr b="1" sz="1300">
+                        <a:defRPr sz="1300" b="1">
                           <a:solidFill>
                             <a:srgbClr val="FFFFFF"/>
                           </a:solidFill>
@@ -7435,7 +7668,7 @@
                     <a:lstStyle/>
                     <a:p>
                       <a:pPr algn="ctr">
-                        <a:defRPr b="1" sz="1300">
+                        <a:defRPr sz="1300" b="1">
                           <a:solidFill>
                             <a:srgbClr val="FFFFFF"/>
                           </a:solidFill>
@@ -7452,6 +7685,11 @@
                     </a:solidFill>
                   </a:tcPr>
                 </a:tc>
+                <a:extLst>
+                  <a:ext uri="{0D108BD9-81ED-4DB2-BD59-A6C34878D82A}">
+                    <a16:rowId xmlns:a16="http://schemas.microsoft.com/office/drawing/2014/main" val="10000"/>
+                  </a:ext>
+                </a:extLst>
               </a:tr>
               <a:tr h="711925">
                 <a:tc>
@@ -7546,6 +7784,11 @@
                     </a:solidFill>
                   </a:tcPr>
                 </a:tc>
+                <a:extLst>
+                  <a:ext uri="{0D108BD9-81ED-4DB2-BD59-A6C34878D82A}">
+                    <a16:rowId xmlns:a16="http://schemas.microsoft.com/office/drawing/2014/main" val="10001"/>
+                  </a:ext>
+                </a:extLst>
               </a:tr>
               <a:tr h="711925">
                 <a:tc>
@@ -7640,6 +7883,11 @@
                     </a:solidFill>
                   </a:tcPr>
                 </a:tc>
+                <a:extLst>
+                  <a:ext uri="{0D108BD9-81ED-4DB2-BD59-A6C34878D82A}">
+                    <a16:rowId xmlns:a16="http://schemas.microsoft.com/office/drawing/2014/main" val="10002"/>
+                  </a:ext>
+                </a:extLst>
               </a:tr>
               <a:tr h="711925">
                 <a:tc>
@@ -7734,6 +7982,11 @@
                     </a:solidFill>
                   </a:tcPr>
                 </a:tc>
+                <a:extLst>
+                  <a:ext uri="{0D108BD9-81ED-4DB2-BD59-A6C34878D82A}">
+                    <a16:rowId xmlns:a16="http://schemas.microsoft.com/office/drawing/2014/main" val="10003"/>
+                  </a:ext>
+                </a:extLst>
               </a:tr>
               <a:tr h="711925">
                 <a:tc>
@@ -7828,6 +8081,11 @@
                     </a:solidFill>
                   </a:tcPr>
                 </a:tc>
+                <a:extLst>
+                  <a:ext uri="{0D108BD9-81ED-4DB2-BD59-A6C34878D82A}">
+                    <a16:rowId xmlns:a16="http://schemas.microsoft.com/office/drawing/2014/main" val="10004"/>
+                  </a:ext>
+                </a:extLst>
               </a:tr>
               <a:tr h="711925">
                 <a:tc>
@@ -7922,6 +8180,11 @@
                     </a:solidFill>
                   </a:tcPr>
                 </a:tc>
+                <a:extLst>
+                  <a:ext uri="{0D108BD9-81ED-4DB2-BD59-A6C34878D82A}">
+                    <a16:rowId xmlns:a16="http://schemas.microsoft.com/office/drawing/2014/main" val="10005"/>
+                  </a:ext>
+                </a:extLst>
               </a:tr>
               <a:tr h="711930">
                 <a:tc>
@@ -7960,6 +8223,7 @@
                         </a:defRPr>
                       </a:pPr>
                       <a:r>
+                        <a:rPr dirty="0"/>
                         <a:t>Requires full reload</a:t>
                       </a:r>
                     </a:p>
@@ -8006,6 +8270,7 @@
                         </a:defRPr>
                       </a:pPr>
                       <a:r>
+                        <a:rPr dirty="0"/>
                         <a:t>Instant Modal Switch with Live State</a:t>
                       </a:r>
                     </a:p>
@@ -8016,6 +8281,11 @@
                     </a:solidFill>
                   </a:tcPr>
                 </a:tc>
+                <a:extLst>
+                  <a:ext uri="{0D108BD9-81ED-4DB2-BD59-A6C34878D82A}">
+                    <a16:rowId xmlns:a16="http://schemas.microsoft.com/office/drawing/2014/main" val="10006"/>
+                  </a:ext>
+                </a:extLst>
               </a:tr>
             </a:tbl>
           </a:graphicData>
@@ -8030,7 +8300,7 @@
 </file>
 
 <file path=ppt/slides/slide5.xml><?xml version="1.0" encoding="utf-8"?>
-<p:sld xmlns:a="http://schemas.openxmlformats.org/drawingml/2006/main" xmlns:p="http://schemas.openxmlformats.org/presentationml/2006/main" xmlns:r="http://schemas.openxmlformats.org/officeDocument/2006/relationships">
+<p:sld xmlns:a="http://schemas.openxmlformats.org/drawingml/2006/main" xmlns:r="http://schemas.openxmlformats.org/officeDocument/2006/relationships" xmlns:p="http://schemas.openxmlformats.org/presentationml/2006/main">
   <p:cSld>
     <p:spTree>
       <p:nvGrpSpPr>
@@ -8038,7 +8308,14 @@
         <p:cNvGrpSpPr/>
         <p:nvPr/>
       </p:nvGrpSpPr>
-      <p:grpSpPr/>
+      <p:grpSpPr>
+        <a:xfrm>
+          <a:off x="0" y="0"/>
+          <a:ext cx="0" cy="0"/>
+          <a:chOff x="0" y="0"/>
+          <a:chExt cx="0" cy="0"/>
+        </a:xfrm>
+      </p:grpSpPr>
       <p:sp>
         <p:nvSpPr>
           <p:cNvPr id="2" name="TextBox 1"/>
@@ -8151,6 +8428,7 @@
           <a:lstStyle/>
           <a:p>
             <a:pPr algn="ctr"/>
+            <a:endParaRPr/>
           </a:p>
         </p:txBody>
       </p:sp>
@@ -8163,7 +8441,7 @@
         <p:spPr>
           <a:xfrm>
             <a:off x="731520" y="6446520"/>
-            <a:ext cx="10728655" cy="274320"/>
+            <a:ext cx="4732065" cy="153888"/>
           </a:xfrm>
           <a:prstGeom prst="rect">
             <a:avLst/>
@@ -8184,7 +8462,8 @@
               </a:defRPr>
             </a:pPr>
             <a:r>
-              <a:t>Career Graph — Project Presentation  |  Group No. 06  |  Department of Computer Engineering / IT</a:t>
+              <a:rPr lang="en-IN" dirty="0"/>
+              <a:t>Career Graph — Project Presentation  |  Group No. 06  |  Department of Computer Science</a:t>
             </a:r>
           </a:p>
         </p:txBody>
@@ -8224,35 +8503,6 @@
           </a:p>
         </p:txBody>
       </p:sp>
-      <p:pic>
-        <p:nvPicPr>
-          <p:cNvPr id="7" name="Picture 6" descr="system_architecture.png"/>
-          <p:cNvPicPr>
-            <a:picLocks noChangeAspect="1"/>
-          </p:cNvPicPr>
-          <p:nvPr/>
-        </p:nvPicPr>
-        <p:blipFill>
-          <a:blip r:embed="rId2"/>
-          <a:stretch>
-            <a:fillRect/>
-          </a:stretch>
-        </p:blipFill>
-        <p:spPr>
-          <a:xfrm>
-            <a:off x="731520" y="1645920"/>
-            <a:ext cx="5394960" cy="4157584"/>
-          </a:xfrm>
-          <a:prstGeom prst="rect">
-            <a:avLst/>
-          </a:prstGeom>
-          <a:ln w="15240">
-            <a:solidFill>
-              <a:srgbClr val="CBD5E1"/>
-            </a:solidFill>
-          </a:ln>
-        </p:spPr>
-      </p:pic>
       <p:sp>
         <p:nvSpPr>
           <p:cNvPr id="8" name="Rounded Rectangle 7"/>
@@ -8295,6 +8545,7 @@
           <a:lstStyle/>
           <a:p>
             <a:pPr algn="ctr"/>
+            <a:endParaRPr/>
           </a:p>
         </p:txBody>
       </p:sp>
@@ -8351,7 +8602,7 @@
           </a:p>
           <a:p>
             <a:pPr>
-              <a:defRPr b="1" sz="1300">
+              <a:defRPr sz="1300" b="1">
                 <a:solidFill>
                   <a:srgbClr val="0F172A"/>
                 </a:solidFill>
@@ -8378,7 +8629,7 @@
           </a:p>
           <a:p>
             <a:pPr>
-              <a:defRPr b="1" sz="1300">
+              <a:defRPr sz="1300" b="1">
                 <a:solidFill>
                   <a:srgbClr val="0F172A"/>
                 </a:solidFill>
@@ -8405,7 +8656,7 @@
           </a:p>
           <a:p>
             <a:pPr>
-              <a:defRPr b="1" sz="1300">
+              <a:defRPr sz="1300" b="1">
                 <a:solidFill>
                   <a:srgbClr val="0F172A"/>
                 </a:solidFill>
@@ -8432,7 +8683,7 @@
           </a:p>
           <a:p>
             <a:pPr>
-              <a:defRPr b="1" sz="1300">
+              <a:defRPr sz="1300" b="1">
                 <a:solidFill>
                   <a:srgbClr val="0F172A"/>
                 </a:solidFill>
@@ -8459,6 +8710,36 @@
           </a:p>
         </p:txBody>
       </p:sp>
+      <p:pic>
+        <p:nvPicPr>
+          <p:cNvPr id="10" name="Picture 9">
+            <a:extLst>
+              <a:ext uri="{FF2B5EF4-FFF2-40B4-BE49-F238E27FC236}">
+                <a16:creationId xmlns:a16="http://schemas.microsoft.com/office/drawing/2014/main" id="{1399F429-E494-D858-FCC3-0E081F5E1C75}"/>
+              </a:ext>
+            </a:extLst>
+          </p:cNvPr>
+          <p:cNvPicPr>
+            <a:picLocks noChangeAspect="1"/>
+          </p:cNvPicPr>
+          <p:nvPr/>
+        </p:nvPicPr>
+        <p:blipFill>
+          <a:blip r:embed="rId2"/>
+          <a:stretch>
+            <a:fillRect/>
+          </a:stretch>
+        </p:blipFill>
+        <p:spPr>
+          <a:xfrm>
+            <a:off x="118393" y="1764792"/>
+            <a:ext cx="6190967" cy="3690182"/>
+          </a:xfrm>
+          <a:prstGeom prst="rect">
+            <a:avLst/>
+          </a:prstGeom>
+        </p:spPr>
+      </p:pic>
     </p:spTree>
   </p:cSld>
   <p:clrMapOvr>
@@ -8468,7 +8749,7 @@
 </file>
 
 <file path=ppt/slides/slide6.xml><?xml version="1.0" encoding="utf-8"?>
-<p:sld xmlns:a="http://schemas.openxmlformats.org/drawingml/2006/main" xmlns:p="http://schemas.openxmlformats.org/presentationml/2006/main" xmlns:r="http://schemas.openxmlformats.org/officeDocument/2006/relationships">
+<p:sld xmlns:a="http://schemas.openxmlformats.org/drawingml/2006/main" xmlns:r="http://schemas.openxmlformats.org/officeDocument/2006/relationships" xmlns:p="http://schemas.openxmlformats.org/presentationml/2006/main">
   <p:cSld>
     <p:spTree>
       <p:nvGrpSpPr>
@@ -8476,7 +8757,14 @@
         <p:cNvGrpSpPr/>
         <p:nvPr/>
       </p:nvGrpSpPr>
-      <p:grpSpPr/>
+      <p:grpSpPr>
+        <a:xfrm>
+          <a:off x="0" y="0"/>
+          <a:ext cx="0" cy="0"/>
+          <a:chOff x="0" y="0"/>
+          <a:chExt cx="0" cy="0"/>
+        </a:xfrm>
+      </p:grpSpPr>
       <p:sp>
         <p:nvSpPr>
           <p:cNvPr id="2" name="TextBox 1"/>
@@ -8589,6 +8877,7 @@
           <a:lstStyle/>
           <a:p>
             <a:pPr algn="ctr"/>
+            <a:endParaRPr/>
           </a:p>
         </p:txBody>
       </p:sp>
@@ -8601,7 +8890,7 @@
         <p:spPr>
           <a:xfrm>
             <a:off x="731520" y="6446520"/>
-            <a:ext cx="10728655" cy="274320"/>
+            <a:ext cx="4732065" cy="153888"/>
           </a:xfrm>
           <a:prstGeom prst="rect">
             <a:avLst/>
@@ -8622,8 +8911,14 @@
               </a:defRPr>
             </a:pPr>
             <a:r>
-              <a:t>Career Graph — Project Presentation  |  Group No. 06  |  Department of Computer Engineering / IT</a:t>
-            </a:r>
+              <a:rPr dirty="0"/>
+              <a:t>Career Graph — Project Presentation  |  Group No. 06  |  Department of Computer </a:t>
+            </a:r>
+            <a:r>
+              <a:rPr lang="en-US" dirty="0"/>
+              <a:t>Science</a:t>
+            </a:r>
+            <a:endParaRPr dirty="0"/>
           </a:p>
         </p:txBody>
       </p:sp>
@@ -8662,35 +8957,6 @@
           </a:p>
         </p:txBody>
       </p:sp>
-      <p:pic>
-        <p:nvPicPr>
-          <p:cNvPr id="7" name="Picture 6" descr="er_diagram.png"/>
-          <p:cNvPicPr>
-            <a:picLocks noChangeAspect="1"/>
-          </p:cNvPicPr>
-          <p:nvPr/>
-        </p:nvPicPr>
-        <p:blipFill>
-          <a:blip r:embed="rId2"/>
-          <a:stretch>
-            <a:fillRect/>
-          </a:stretch>
-        </p:blipFill>
-        <p:spPr>
-          <a:xfrm>
-            <a:off x="731520" y="1645920"/>
-            <a:ext cx="5394960" cy="4117206"/>
-          </a:xfrm>
-          <a:prstGeom prst="rect">
-            <a:avLst/>
-          </a:prstGeom>
-          <a:ln w="15240">
-            <a:solidFill>
-              <a:srgbClr val="CBD5E1"/>
-            </a:solidFill>
-          </a:ln>
-        </p:spPr>
-      </p:pic>
       <p:sp>
         <p:nvSpPr>
           <p:cNvPr id="8" name="Rounded Rectangle 7"/>
@@ -8733,6 +8999,7 @@
           <a:lstStyle/>
           <a:p>
             <a:pPr algn="ctr"/>
+            <a:endParaRPr/>
           </a:p>
         </p:txBody>
       </p:sp>
@@ -8789,7 +9056,7 @@
           </a:p>
           <a:p>
             <a:pPr>
-              <a:defRPr b="1" sz="1300">
+              <a:defRPr sz="1300" b="1">
                 <a:solidFill>
                   <a:srgbClr val="0F172A"/>
                 </a:solidFill>
@@ -8816,7 +9083,7 @@
           </a:p>
           <a:p>
             <a:pPr>
-              <a:defRPr b="1" sz="1300">
+              <a:defRPr sz="1300" b="1">
                 <a:solidFill>
                   <a:srgbClr val="0F172A"/>
                 </a:solidFill>
@@ -8843,7 +9110,7 @@
           </a:p>
           <a:p>
             <a:pPr>
-              <a:defRPr b="1" sz="1300">
+              <a:defRPr sz="1300" b="1">
                 <a:solidFill>
                   <a:srgbClr val="0F172A"/>
                 </a:solidFill>
@@ -8870,7 +9137,7 @@
           </a:p>
           <a:p>
             <a:pPr>
-              <a:defRPr b="1" sz="1300">
+              <a:defRPr sz="1300" b="1">
                 <a:solidFill>
                   <a:srgbClr val="0F172A"/>
                 </a:solidFill>
@@ -8897,7 +9164,7 @@
           </a:p>
           <a:p>
             <a:pPr>
-              <a:defRPr b="1" sz="1300">
+              <a:defRPr sz="1300" b="1">
                 <a:solidFill>
                   <a:srgbClr val="0F172A"/>
                 </a:solidFill>
@@ -8924,6 +9191,36 @@
           </a:p>
         </p:txBody>
       </p:sp>
+      <p:pic>
+        <p:nvPicPr>
+          <p:cNvPr id="10" name="Picture 9">
+            <a:extLst>
+              <a:ext uri="{FF2B5EF4-FFF2-40B4-BE49-F238E27FC236}">
+                <a16:creationId xmlns:a16="http://schemas.microsoft.com/office/drawing/2014/main" id="{C42D3E92-A6B0-A667-DCF4-8E79DFFC4FE6}"/>
+              </a:ext>
+            </a:extLst>
+          </p:cNvPr>
+          <p:cNvPicPr>
+            <a:picLocks noChangeAspect="1"/>
+          </p:cNvPicPr>
+          <p:nvPr/>
+        </p:nvPicPr>
+        <p:blipFill>
+          <a:blip r:embed="rId2"/>
+          <a:stretch>
+            <a:fillRect/>
+          </a:stretch>
+        </p:blipFill>
+        <p:spPr>
+          <a:xfrm>
+            <a:off x="170196" y="1600200"/>
+            <a:ext cx="6108989" cy="4142232"/>
+          </a:xfrm>
+          <a:prstGeom prst="rect">
+            <a:avLst/>
+          </a:prstGeom>
+        </p:spPr>
+      </p:pic>
     </p:spTree>
   </p:cSld>
   <p:clrMapOvr>
@@ -8933,7 +9230,7 @@
 </file>
 
 <file path=ppt/slides/slide7.xml><?xml version="1.0" encoding="utf-8"?>
-<p:sld xmlns:a="http://schemas.openxmlformats.org/drawingml/2006/main" xmlns:p="http://schemas.openxmlformats.org/presentationml/2006/main" xmlns:r="http://schemas.openxmlformats.org/officeDocument/2006/relationships">
+<p:sld xmlns:a="http://schemas.openxmlformats.org/drawingml/2006/main" xmlns:r="http://schemas.openxmlformats.org/officeDocument/2006/relationships" xmlns:p="http://schemas.openxmlformats.org/presentationml/2006/main">
   <p:cSld>
     <p:spTree>
       <p:nvGrpSpPr>
@@ -8941,7 +9238,14 @@
         <p:cNvGrpSpPr/>
         <p:nvPr/>
       </p:nvGrpSpPr>
-      <p:grpSpPr/>
+      <p:grpSpPr>
+        <a:xfrm>
+          <a:off x="0" y="0"/>
+          <a:ext cx="0" cy="0"/>
+          <a:chOff x="0" y="0"/>
+          <a:chExt cx="0" cy="0"/>
+        </a:xfrm>
+      </p:grpSpPr>
       <p:sp>
         <p:nvSpPr>
           <p:cNvPr id="2" name="TextBox 1"/>
@@ -9054,6 +9358,7 @@
           <a:lstStyle/>
           <a:p>
             <a:pPr algn="ctr"/>
+            <a:endParaRPr/>
           </a:p>
         </p:txBody>
       </p:sp>
@@ -9066,7 +9371,7 @@
         <p:spPr>
           <a:xfrm>
             <a:off x="731520" y="6446520"/>
-            <a:ext cx="10728655" cy="274320"/>
+            <a:ext cx="4732065" cy="153888"/>
           </a:xfrm>
           <a:prstGeom prst="rect">
             <a:avLst/>
@@ -9087,7 +9392,8 @@
               </a:defRPr>
             </a:pPr>
             <a:r>
-              <a:t>Career Graph — Project Presentation  |  Group No. 06  |  Department of Computer Engineering / IT</a:t>
+              <a:rPr lang="en-IN" dirty="0"/>
+              <a:t>Career Graph — Project Presentation  |  Group No. 06  |  Department of Computer Science</a:t>
             </a:r>
           </a:p>
         </p:txBody>
@@ -9134,6 +9440,7 @@
           <a:lstStyle/>
           <a:p>
             <a:pPr algn="ctr"/>
+            <a:endParaRPr/>
           </a:p>
         </p:txBody>
       </p:sp>
@@ -9274,6 +9581,7 @@
           <a:lstStyle/>
           <a:p>
             <a:pPr algn="ctr"/>
+            <a:endParaRPr/>
           </a:p>
         </p:txBody>
       </p:sp>
@@ -9414,6 +9722,7 @@
           <a:lstStyle/>
           <a:p>
             <a:pPr algn="ctr"/>
+            <a:endParaRPr/>
           </a:p>
         </p:txBody>
       </p:sp>
@@ -9426,7 +9735,7 @@
         <p:spPr>
           <a:xfrm>
             <a:off x="8311896" y="1481328"/>
-            <a:ext cx="2926080" cy="3063240"/>
+            <a:ext cx="2926080" cy="1620957"/>
           </a:xfrm>
           <a:prstGeom prst="rect">
             <a:avLst/>
@@ -9447,6 +9756,7 @@
               </a:defRPr>
             </a:pPr>
             <a:r>
+              <a:rPr dirty="0"/>
               <a:t>Phase 3: Advanced</a:t>
             </a:r>
           </a:p>
@@ -9462,6 +9772,7 @@
               </a:defRPr>
             </a:pPr>
             <a:r>
+              <a:rPr dirty="0"/>
               <a:t>PRODUCTION &amp; CLOUD</a:t>
             </a:r>
           </a:p>
@@ -9477,6 +9788,7 @@
               </a:defRPr>
             </a:pPr>
             <a:r>
+              <a:rPr dirty="0"/>
               <a:t>• STRICTLY LOCKED until all Phase 2 skills are verified or completed.</a:t>
             </a:r>
           </a:p>
@@ -9492,8 +9804,14 @@
               </a:defRPr>
             </a:pPr>
             <a:r>
-              <a:t>• Tools: Docker, AWS Cloud, Kubernetes, CI/CD.</a:t>
-            </a:r>
+              <a:rPr dirty="0"/>
+              <a:t>• Tools: </a:t>
+            </a:r>
+            <a:r>
+              <a:rPr lang="en-US" dirty="0" err="1"/>
+              <a:t>Mongodb</a:t>
+            </a:r>
+            <a:endParaRPr lang="en-US" dirty="0"/>
           </a:p>
           <a:p>
             <a:pPr>
@@ -9507,6 +9825,7 @@
               </a:defRPr>
             </a:pPr>
             <a:r>
+              <a:rPr dirty="0"/>
               <a:t>• Ensures code literacy and API proficiency prior to containerized deployments.</a:t>
             </a:r>
           </a:p>
@@ -9554,6 +9873,7 @@
           <a:lstStyle/>
           <a:p>
             <a:pPr algn="ctr"/>
+            <a:endParaRPr/>
           </a:p>
         </p:txBody>
       </p:sp>
@@ -9583,7 +9903,7 @@
               <a:spcAft>
                 <a:spcPts val="400"/>
               </a:spcAft>
-              <a:defRPr b="1" sz="1400">
+              <a:defRPr sz="1400" b="1">
                 <a:solidFill>
                   <a:srgbClr val="1E3A8A"/>
                 </a:solidFill>
@@ -9616,7 +9936,7 @@
 </file>
 
 <file path=ppt/slides/slide8.xml><?xml version="1.0" encoding="utf-8"?>
-<p:sld xmlns:a="http://schemas.openxmlformats.org/drawingml/2006/main" xmlns:p="http://schemas.openxmlformats.org/presentationml/2006/main" xmlns:r="http://schemas.openxmlformats.org/officeDocument/2006/relationships">
+<p:sld xmlns:a="http://schemas.openxmlformats.org/drawingml/2006/main" xmlns:r="http://schemas.openxmlformats.org/officeDocument/2006/relationships" xmlns:p="http://schemas.openxmlformats.org/presentationml/2006/main">
   <p:cSld>
     <p:spTree>
       <p:nvGrpSpPr>
@@ -9624,7 +9944,14 @@
         <p:cNvGrpSpPr/>
         <p:nvPr/>
       </p:nvGrpSpPr>
-      <p:grpSpPr/>
+      <p:grpSpPr>
+        <a:xfrm>
+          <a:off x="0" y="0"/>
+          <a:ext cx="0" cy="0"/>
+          <a:chOff x="0" y="0"/>
+          <a:chExt cx="0" cy="0"/>
+        </a:xfrm>
+      </p:grpSpPr>
       <p:sp>
         <p:nvSpPr>
           <p:cNvPr id="2" name="TextBox 1"/>
@@ -9737,6 +10064,7 @@
           <a:lstStyle/>
           <a:p>
             <a:pPr algn="ctr"/>
+            <a:endParaRPr/>
           </a:p>
         </p:txBody>
       </p:sp>
@@ -9749,7 +10077,7 @@
         <p:spPr>
           <a:xfrm>
             <a:off x="731520" y="6446520"/>
-            <a:ext cx="10728655" cy="274320"/>
+            <a:ext cx="4732065" cy="153888"/>
           </a:xfrm>
           <a:prstGeom prst="rect">
             <a:avLst/>
@@ -9770,7 +10098,8 @@
               </a:defRPr>
             </a:pPr>
             <a:r>
-              <a:t>Career Graph — Project Presentation  |  Group No. 06  |  Department of Computer Engineering / IT</a:t>
+              <a:rPr lang="en-IN" dirty="0"/>
+              <a:t>Career Graph — Project Presentation  |  Group No. 06  |  Department of Computer Science</a:t>
             </a:r>
           </a:p>
         </p:txBody>
@@ -9817,6 +10146,7 @@
           <a:lstStyle/>
           <a:p>
             <a:pPr algn="ctr"/>
+            <a:endParaRPr/>
           </a:p>
         </p:txBody>
       </p:sp>
@@ -9957,6 +10287,7 @@
           <a:lstStyle/>
           <a:p>
             <a:pPr algn="ctr"/>
+            <a:endParaRPr/>
           </a:p>
         </p:txBody>
       </p:sp>
@@ -10082,6 +10413,7 @@
           <a:lstStyle/>
           <a:p>
             <a:pPr algn="ctr"/>
+            <a:endParaRPr/>
           </a:p>
         </p:txBody>
       </p:sp>
@@ -10222,6 +10554,7 @@
           <a:lstStyle/>
           <a:p>
             <a:pPr algn="ctr"/>
+            <a:endParaRPr/>
           </a:p>
         </p:txBody>
       </p:sp>
@@ -10251,7 +10584,7 @@
               <a:spcAft>
                 <a:spcPts val="400"/>
               </a:spcAft>
-              <a:defRPr b="1" sz="1400">
+              <a:defRPr sz="1400" b="1">
                 <a:solidFill>
                   <a:srgbClr val="166534"/>
                 </a:solidFill>
@@ -10284,7 +10617,7 @@
 </file>
 
 <file path=ppt/slides/slide9.xml><?xml version="1.0" encoding="utf-8"?>
-<p:sld xmlns:a="http://schemas.openxmlformats.org/drawingml/2006/main" xmlns:p="http://schemas.openxmlformats.org/presentationml/2006/main" xmlns:r="http://schemas.openxmlformats.org/officeDocument/2006/relationships">
+<p:sld xmlns:a="http://schemas.openxmlformats.org/drawingml/2006/main" xmlns:r="http://schemas.openxmlformats.org/officeDocument/2006/relationships" xmlns:p="http://schemas.openxmlformats.org/presentationml/2006/main">
   <p:cSld>
     <p:spTree>
       <p:nvGrpSpPr>
@@ -10292,7 +10625,14 @@
         <p:cNvGrpSpPr/>
         <p:nvPr/>
       </p:nvGrpSpPr>
-      <p:grpSpPr/>
+      <p:grpSpPr>
+        <a:xfrm>
+          <a:off x="0" y="0"/>
+          <a:ext cx="0" cy="0"/>
+          <a:chOff x="0" y="0"/>
+          <a:chExt cx="0" cy="0"/>
+        </a:xfrm>
+      </p:grpSpPr>
       <p:sp>
         <p:nvSpPr>
           <p:cNvPr id="2" name="TextBox 1"/>
@@ -10405,6 +10745,7 @@
           <a:lstStyle/>
           <a:p>
             <a:pPr algn="ctr"/>
+            <a:endParaRPr/>
           </a:p>
         </p:txBody>
       </p:sp>
@@ -10417,7 +10758,7 @@
         <p:spPr>
           <a:xfrm>
             <a:off x="731520" y="6446520"/>
-            <a:ext cx="10728655" cy="274320"/>
+            <a:ext cx="4732065" cy="153888"/>
           </a:xfrm>
           <a:prstGeom prst="rect">
             <a:avLst/>
@@ -10438,7 +10779,8 @@
               </a:defRPr>
             </a:pPr>
             <a:r>
-              <a:t>Career Graph — Project Presentation  |  Group No. 06  |  Department of Computer Engineering / IT</a:t>
+              <a:rPr lang="en-IN" dirty="0"/>
+              <a:t>Career Graph — Project Presentation  |  Group No. 06  |  Department of Computer Science</a:t>
             </a:r>
           </a:p>
         </p:txBody>
@@ -10485,6 +10827,7 @@
           <a:lstStyle/>
           <a:p>
             <a:pPr algn="ctr"/>
+            <a:endParaRPr/>
           </a:p>
         </p:txBody>
       </p:sp>
@@ -10514,7 +10857,7 @@
               <a:spcAft>
                 <a:spcPts val="300"/>
               </a:spcAft>
-              <a:defRPr b="1" sz="1600">
+              <a:defRPr sz="1600" b="1">
                 <a:solidFill>
                   <a:srgbClr val="1E3A8A"/>
                 </a:solidFill>
@@ -10643,6 +10986,7 @@
           <a:lstStyle/>
           <a:p>
             <a:pPr algn="ctr"/>
+            <a:endParaRPr/>
           </a:p>
         </p:txBody>
       </p:sp>
@@ -10672,7 +11016,7 @@
               <a:spcAft>
                 <a:spcPts val="300"/>
               </a:spcAft>
-              <a:defRPr b="1" sz="1600">
+              <a:defRPr sz="1600" b="1">
                 <a:solidFill>
                   <a:srgbClr val="166534"/>
                 </a:solidFill>
@@ -10801,6 +11145,7 @@
           <a:lstStyle/>
           <a:p>
             <a:pPr algn="ctr"/>
+            <a:endParaRPr/>
           </a:p>
         </p:txBody>
       </p:sp>
@@ -10830,7 +11175,7 @@
               <a:spcAft>
                 <a:spcPts val="400"/>
               </a:spcAft>
-              <a:defRPr b="1" sz="1400">
+              <a:defRPr sz="1400" b="1">
                 <a:solidFill>
                   <a:srgbClr val="1E3A8A"/>
                 </a:solidFill>

</xml_diff>